<commit_message>
feat(ppt): remove subtitle text from export modal and adapt exporter to user's updated 15-slide Template PPT.pptx
</commit_message>
<xml_diff>
--- a/Template PPT.pptx
+++ b/Template PPT.pptx
@@ -5,12 +5,24 @@
     <p:sldMasterId id="2147483648" r:id="rId1"/>
   </p:sldMasterIdLst>
   <p:notesMasterIdLst>
-    <p:notesMasterId r:id="rId5"/>
+    <p:notesMasterId r:id="rId17"/>
   </p:notesMasterIdLst>
   <p:sldIdLst>
     <p:sldId id="256" r:id="rId2"/>
     <p:sldId id="258" r:id="rId3"/>
-    <p:sldId id="259" r:id="rId4"/>
+    <p:sldId id="260" r:id="rId4"/>
+    <p:sldId id="261" r:id="rId5"/>
+    <p:sldId id="262" r:id="rId6"/>
+    <p:sldId id="263" r:id="rId7"/>
+    <p:sldId id="270" r:id="rId8"/>
+    <p:sldId id="271" r:id="rId9"/>
+    <p:sldId id="266" r:id="rId10"/>
+    <p:sldId id="269" r:id="rId11"/>
+    <p:sldId id="267" r:id="rId12"/>
+    <p:sldId id="268" r:id="rId13"/>
+    <p:sldId id="265" r:id="rId14"/>
+    <p:sldId id="264" r:id="rId15"/>
+    <p:sldId id="259" r:id="rId16"/>
   </p:sldIdLst>
   <p:sldSz cx="9144000" cy="5143500" type="screen16x9"/>
   <p:notesSz cx="6858000" cy="9144000"/>
@@ -807,6 +819,745 @@
 </p:notes>
 </file>
 
+<file path=ppt/notesSlides/notesSlide10.xml><?xml version="1.0" encoding="utf-8"?>
+<p:notes xmlns:a="http://schemas.openxmlformats.org/drawingml/2006/main" xmlns:r="http://schemas.openxmlformats.org/officeDocument/2006/relationships" xmlns:p="http://schemas.openxmlformats.org/presentationml/2006/main" showMasterSp="0" showMasterPhAnim="0">
+  <p:cSld>
+    <p:spTree>
+      <p:nvGrpSpPr>
+        <p:cNvPr id="1" name="Shape 62">
+          <a:extLst>
+            <a:ext uri="{FF2B5EF4-FFF2-40B4-BE49-F238E27FC236}">
+              <a16:creationId xmlns:a16="http://schemas.microsoft.com/office/drawing/2014/main" id="{61B7D0EF-016A-4A7C-878B-8EBE05F3BD68}"/>
+            </a:ext>
+          </a:extLst>
+        </p:cNvPr>
+        <p:cNvGrpSpPr/>
+        <p:nvPr/>
+      </p:nvGrpSpPr>
+      <p:grpSpPr>
+        <a:xfrm>
+          <a:off x="0" y="0"/>
+          <a:ext cx="0" cy="0"/>
+          <a:chOff x="0" y="0"/>
+          <a:chExt cx="0" cy="0"/>
+        </a:xfrm>
+      </p:grpSpPr>
+      <p:sp>
+        <p:nvSpPr>
+          <p:cNvPr id="63" name="Google Shape;63;g359956e13c8_0_5:notes">
+            <a:extLst>
+              <a:ext uri="{FF2B5EF4-FFF2-40B4-BE49-F238E27FC236}">
+                <a16:creationId xmlns:a16="http://schemas.microsoft.com/office/drawing/2014/main" id="{2330CD92-FF13-3B9D-AE96-7F27438395DE}"/>
+              </a:ext>
+            </a:extLst>
+          </p:cNvPr>
+          <p:cNvSpPr>
+            <a:spLocks noGrp="1" noRot="1" noChangeAspect="1"/>
+          </p:cNvSpPr>
+          <p:nvPr>
+            <p:ph type="sldImg" idx="2"/>
+          </p:nvPr>
+        </p:nvSpPr>
+        <p:spPr>
+          <a:xfrm>
+            <a:off x="381000" y="685800"/>
+            <a:ext cx="6096000" cy="3429000"/>
+          </a:xfrm>
+          <a:custGeom>
+            <a:avLst/>
+            <a:gdLst/>
+            <a:ahLst/>
+            <a:cxnLst/>
+            <a:rect l="l" t="t" r="r" b="b"/>
+            <a:pathLst>
+              <a:path w="120000" h="120000" extrusionOk="0">
+                <a:moveTo>
+                  <a:pt x="0" y="0"/>
+                </a:moveTo>
+                <a:lnTo>
+                  <a:pt x="120000" y="0"/>
+                </a:lnTo>
+                <a:lnTo>
+                  <a:pt x="120000" y="120000"/>
+                </a:lnTo>
+                <a:lnTo>
+                  <a:pt x="0" y="120000"/>
+                </a:lnTo>
+                <a:close/>
+              </a:path>
+            </a:pathLst>
+          </a:custGeom>
+        </p:spPr>
+      </p:sp>
+      <p:sp>
+        <p:nvSpPr>
+          <p:cNvPr id="64" name="Google Shape;64;g359956e13c8_0_5:notes">
+            <a:extLst>
+              <a:ext uri="{FF2B5EF4-FFF2-40B4-BE49-F238E27FC236}">
+                <a16:creationId xmlns:a16="http://schemas.microsoft.com/office/drawing/2014/main" id="{8211F923-B081-362B-0760-DFA7DBD0EB30}"/>
+              </a:ext>
+            </a:extLst>
+          </p:cNvPr>
+          <p:cNvSpPr txBox="1">
+            <a:spLocks noGrp="1"/>
+          </p:cNvSpPr>
+          <p:nvPr>
+            <p:ph type="body" idx="1"/>
+          </p:nvPr>
+        </p:nvSpPr>
+        <p:spPr>
+          <a:xfrm>
+            <a:off x="685800" y="4343400"/>
+            <a:ext cx="5486400" cy="4114800"/>
+          </a:xfrm>
+          <a:prstGeom prst="rect">
+            <a:avLst/>
+          </a:prstGeom>
+        </p:spPr>
+        <p:txBody>
+          <a:bodyPr spcFirstLastPara="1" wrap="square" lIns="91425" tIns="91425" rIns="91425" bIns="91425" anchor="t" anchorCtr="0">
+            <a:noAutofit/>
+          </a:bodyPr>
+          <a:lstStyle/>
+          <a:p>
+            <a:pPr marL="0" lvl="0" indent="0" algn="l" rtl="0">
+              <a:spcBef>
+                <a:spcPts val="0"/>
+              </a:spcBef>
+              <a:spcAft>
+                <a:spcPts val="0"/>
+              </a:spcAft>
+              <a:buNone/>
+            </a:pPr>
+            <a:endParaRPr/>
+          </a:p>
+        </p:txBody>
+      </p:sp>
+    </p:spTree>
+    <p:extLst>
+      <p:ext uri="{BB962C8B-B14F-4D97-AF65-F5344CB8AC3E}">
+        <p14:creationId xmlns:p14="http://schemas.microsoft.com/office/powerpoint/2010/main" val="782501518"/>
+      </p:ext>
+    </p:extLst>
+  </p:cSld>
+  <p:clrMapOvr>
+    <a:masterClrMapping/>
+  </p:clrMapOvr>
+</p:notes>
+</file>
+
+<file path=ppt/notesSlides/notesSlide11.xml><?xml version="1.0" encoding="utf-8"?>
+<p:notes xmlns:a="http://schemas.openxmlformats.org/drawingml/2006/main" xmlns:r="http://schemas.openxmlformats.org/officeDocument/2006/relationships" xmlns:p="http://schemas.openxmlformats.org/presentationml/2006/main" showMasterSp="0" showMasterPhAnim="0">
+  <p:cSld>
+    <p:spTree>
+      <p:nvGrpSpPr>
+        <p:cNvPr id="1" name="Shape 62">
+          <a:extLst>
+            <a:ext uri="{FF2B5EF4-FFF2-40B4-BE49-F238E27FC236}">
+              <a16:creationId xmlns:a16="http://schemas.microsoft.com/office/drawing/2014/main" id="{A9035E2A-A1D9-CF75-9035-E0C41B14C706}"/>
+            </a:ext>
+          </a:extLst>
+        </p:cNvPr>
+        <p:cNvGrpSpPr/>
+        <p:nvPr/>
+      </p:nvGrpSpPr>
+      <p:grpSpPr>
+        <a:xfrm>
+          <a:off x="0" y="0"/>
+          <a:ext cx="0" cy="0"/>
+          <a:chOff x="0" y="0"/>
+          <a:chExt cx="0" cy="0"/>
+        </a:xfrm>
+      </p:grpSpPr>
+      <p:sp>
+        <p:nvSpPr>
+          <p:cNvPr id="63" name="Google Shape;63;g359956e13c8_0_5:notes">
+            <a:extLst>
+              <a:ext uri="{FF2B5EF4-FFF2-40B4-BE49-F238E27FC236}">
+                <a16:creationId xmlns:a16="http://schemas.microsoft.com/office/drawing/2014/main" id="{8105034D-FD2B-1CD5-D5EA-B1C8FA1FAC79}"/>
+              </a:ext>
+            </a:extLst>
+          </p:cNvPr>
+          <p:cNvSpPr>
+            <a:spLocks noGrp="1" noRot="1" noChangeAspect="1"/>
+          </p:cNvSpPr>
+          <p:nvPr>
+            <p:ph type="sldImg" idx="2"/>
+          </p:nvPr>
+        </p:nvSpPr>
+        <p:spPr>
+          <a:xfrm>
+            <a:off x="381000" y="685800"/>
+            <a:ext cx="6096000" cy="3429000"/>
+          </a:xfrm>
+          <a:custGeom>
+            <a:avLst/>
+            <a:gdLst/>
+            <a:ahLst/>
+            <a:cxnLst/>
+            <a:rect l="l" t="t" r="r" b="b"/>
+            <a:pathLst>
+              <a:path w="120000" h="120000" extrusionOk="0">
+                <a:moveTo>
+                  <a:pt x="0" y="0"/>
+                </a:moveTo>
+                <a:lnTo>
+                  <a:pt x="120000" y="0"/>
+                </a:lnTo>
+                <a:lnTo>
+                  <a:pt x="120000" y="120000"/>
+                </a:lnTo>
+                <a:lnTo>
+                  <a:pt x="0" y="120000"/>
+                </a:lnTo>
+                <a:close/>
+              </a:path>
+            </a:pathLst>
+          </a:custGeom>
+        </p:spPr>
+      </p:sp>
+      <p:sp>
+        <p:nvSpPr>
+          <p:cNvPr id="64" name="Google Shape;64;g359956e13c8_0_5:notes">
+            <a:extLst>
+              <a:ext uri="{FF2B5EF4-FFF2-40B4-BE49-F238E27FC236}">
+                <a16:creationId xmlns:a16="http://schemas.microsoft.com/office/drawing/2014/main" id="{2B995F57-B596-1FB8-2F5E-F279AD4CA26D}"/>
+              </a:ext>
+            </a:extLst>
+          </p:cNvPr>
+          <p:cNvSpPr txBox="1">
+            <a:spLocks noGrp="1"/>
+          </p:cNvSpPr>
+          <p:nvPr>
+            <p:ph type="body" idx="1"/>
+          </p:nvPr>
+        </p:nvSpPr>
+        <p:spPr>
+          <a:xfrm>
+            <a:off x="685800" y="4343400"/>
+            <a:ext cx="5486400" cy="4114800"/>
+          </a:xfrm>
+          <a:prstGeom prst="rect">
+            <a:avLst/>
+          </a:prstGeom>
+        </p:spPr>
+        <p:txBody>
+          <a:bodyPr spcFirstLastPara="1" wrap="square" lIns="91425" tIns="91425" rIns="91425" bIns="91425" anchor="t" anchorCtr="0">
+            <a:noAutofit/>
+          </a:bodyPr>
+          <a:lstStyle/>
+          <a:p>
+            <a:pPr marL="0" lvl="0" indent="0" algn="l" rtl="0">
+              <a:spcBef>
+                <a:spcPts val="0"/>
+              </a:spcBef>
+              <a:spcAft>
+                <a:spcPts val="0"/>
+              </a:spcAft>
+              <a:buNone/>
+            </a:pPr>
+            <a:endParaRPr/>
+          </a:p>
+        </p:txBody>
+      </p:sp>
+    </p:spTree>
+    <p:extLst>
+      <p:ext uri="{BB962C8B-B14F-4D97-AF65-F5344CB8AC3E}">
+        <p14:creationId xmlns:p14="http://schemas.microsoft.com/office/powerpoint/2010/main" val="3617224655"/>
+      </p:ext>
+    </p:extLst>
+  </p:cSld>
+  <p:clrMapOvr>
+    <a:masterClrMapping/>
+  </p:clrMapOvr>
+</p:notes>
+</file>
+
+<file path=ppt/notesSlides/notesSlide12.xml><?xml version="1.0" encoding="utf-8"?>
+<p:notes xmlns:a="http://schemas.openxmlformats.org/drawingml/2006/main" xmlns:r="http://schemas.openxmlformats.org/officeDocument/2006/relationships" xmlns:p="http://schemas.openxmlformats.org/presentationml/2006/main" showMasterSp="0" showMasterPhAnim="0">
+  <p:cSld>
+    <p:spTree>
+      <p:nvGrpSpPr>
+        <p:cNvPr id="1" name="Shape 62">
+          <a:extLst>
+            <a:ext uri="{FF2B5EF4-FFF2-40B4-BE49-F238E27FC236}">
+              <a16:creationId xmlns:a16="http://schemas.microsoft.com/office/drawing/2014/main" id="{43A8F4B5-84C3-A1C7-769E-CCA180E058D0}"/>
+            </a:ext>
+          </a:extLst>
+        </p:cNvPr>
+        <p:cNvGrpSpPr/>
+        <p:nvPr/>
+      </p:nvGrpSpPr>
+      <p:grpSpPr>
+        <a:xfrm>
+          <a:off x="0" y="0"/>
+          <a:ext cx="0" cy="0"/>
+          <a:chOff x="0" y="0"/>
+          <a:chExt cx="0" cy="0"/>
+        </a:xfrm>
+      </p:grpSpPr>
+      <p:sp>
+        <p:nvSpPr>
+          <p:cNvPr id="63" name="Google Shape;63;g359956e13c8_0_5:notes">
+            <a:extLst>
+              <a:ext uri="{FF2B5EF4-FFF2-40B4-BE49-F238E27FC236}">
+                <a16:creationId xmlns:a16="http://schemas.microsoft.com/office/drawing/2014/main" id="{7CF7AAB0-44D6-D635-BD4B-8C3F5D2F9942}"/>
+              </a:ext>
+            </a:extLst>
+          </p:cNvPr>
+          <p:cNvSpPr>
+            <a:spLocks noGrp="1" noRot="1" noChangeAspect="1"/>
+          </p:cNvSpPr>
+          <p:nvPr>
+            <p:ph type="sldImg" idx="2"/>
+          </p:nvPr>
+        </p:nvSpPr>
+        <p:spPr>
+          <a:xfrm>
+            <a:off x="381000" y="685800"/>
+            <a:ext cx="6096000" cy="3429000"/>
+          </a:xfrm>
+          <a:custGeom>
+            <a:avLst/>
+            <a:gdLst/>
+            <a:ahLst/>
+            <a:cxnLst/>
+            <a:rect l="l" t="t" r="r" b="b"/>
+            <a:pathLst>
+              <a:path w="120000" h="120000" extrusionOk="0">
+                <a:moveTo>
+                  <a:pt x="0" y="0"/>
+                </a:moveTo>
+                <a:lnTo>
+                  <a:pt x="120000" y="0"/>
+                </a:lnTo>
+                <a:lnTo>
+                  <a:pt x="120000" y="120000"/>
+                </a:lnTo>
+                <a:lnTo>
+                  <a:pt x="0" y="120000"/>
+                </a:lnTo>
+                <a:close/>
+              </a:path>
+            </a:pathLst>
+          </a:custGeom>
+        </p:spPr>
+      </p:sp>
+      <p:sp>
+        <p:nvSpPr>
+          <p:cNvPr id="64" name="Google Shape;64;g359956e13c8_0_5:notes">
+            <a:extLst>
+              <a:ext uri="{FF2B5EF4-FFF2-40B4-BE49-F238E27FC236}">
+                <a16:creationId xmlns:a16="http://schemas.microsoft.com/office/drawing/2014/main" id="{0A8FE482-77A2-3F2F-5CE1-93F303471E8F}"/>
+              </a:ext>
+            </a:extLst>
+          </p:cNvPr>
+          <p:cNvSpPr txBox="1">
+            <a:spLocks noGrp="1"/>
+          </p:cNvSpPr>
+          <p:nvPr>
+            <p:ph type="body" idx="1"/>
+          </p:nvPr>
+        </p:nvSpPr>
+        <p:spPr>
+          <a:xfrm>
+            <a:off x="685800" y="4343400"/>
+            <a:ext cx="5486400" cy="4114800"/>
+          </a:xfrm>
+          <a:prstGeom prst="rect">
+            <a:avLst/>
+          </a:prstGeom>
+        </p:spPr>
+        <p:txBody>
+          <a:bodyPr spcFirstLastPara="1" wrap="square" lIns="91425" tIns="91425" rIns="91425" bIns="91425" anchor="t" anchorCtr="0">
+            <a:noAutofit/>
+          </a:bodyPr>
+          <a:lstStyle/>
+          <a:p>
+            <a:pPr marL="0" lvl="0" indent="0" algn="l" rtl="0">
+              <a:spcBef>
+                <a:spcPts val="0"/>
+              </a:spcBef>
+              <a:spcAft>
+                <a:spcPts val="0"/>
+              </a:spcAft>
+              <a:buNone/>
+            </a:pPr>
+            <a:endParaRPr/>
+          </a:p>
+        </p:txBody>
+      </p:sp>
+    </p:spTree>
+    <p:extLst>
+      <p:ext uri="{BB962C8B-B14F-4D97-AF65-F5344CB8AC3E}">
+        <p14:creationId xmlns:p14="http://schemas.microsoft.com/office/powerpoint/2010/main" val="1578608578"/>
+      </p:ext>
+    </p:extLst>
+  </p:cSld>
+  <p:clrMapOvr>
+    <a:masterClrMapping/>
+  </p:clrMapOvr>
+</p:notes>
+</file>
+
+<file path=ppt/notesSlides/notesSlide13.xml><?xml version="1.0" encoding="utf-8"?>
+<p:notes xmlns:a="http://schemas.openxmlformats.org/drawingml/2006/main" xmlns:r="http://schemas.openxmlformats.org/officeDocument/2006/relationships" xmlns:p="http://schemas.openxmlformats.org/presentationml/2006/main" showMasterSp="0" showMasterPhAnim="0">
+  <p:cSld>
+    <p:spTree>
+      <p:nvGrpSpPr>
+        <p:cNvPr id="1" name="Shape 62">
+          <a:extLst>
+            <a:ext uri="{FF2B5EF4-FFF2-40B4-BE49-F238E27FC236}">
+              <a16:creationId xmlns:a16="http://schemas.microsoft.com/office/drawing/2014/main" id="{1C159C1C-07D8-CC85-D0BC-41A817854151}"/>
+            </a:ext>
+          </a:extLst>
+        </p:cNvPr>
+        <p:cNvGrpSpPr/>
+        <p:nvPr/>
+      </p:nvGrpSpPr>
+      <p:grpSpPr>
+        <a:xfrm>
+          <a:off x="0" y="0"/>
+          <a:ext cx="0" cy="0"/>
+          <a:chOff x="0" y="0"/>
+          <a:chExt cx="0" cy="0"/>
+        </a:xfrm>
+      </p:grpSpPr>
+      <p:sp>
+        <p:nvSpPr>
+          <p:cNvPr id="63" name="Google Shape;63;g359956e13c8_0_5:notes">
+            <a:extLst>
+              <a:ext uri="{FF2B5EF4-FFF2-40B4-BE49-F238E27FC236}">
+                <a16:creationId xmlns:a16="http://schemas.microsoft.com/office/drawing/2014/main" id="{18E5637A-5D45-6440-550F-265BD4B5363E}"/>
+              </a:ext>
+            </a:extLst>
+          </p:cNvPr>
+          <p:cNvSpPr>
+            <a:spLocks noGrp="1" noRot="1" noChangeAspect="1"/>
+          </p:cNvSpPr>
+          <p:nvPr>
+            <p:ph type="sldImg" idx="2"/>
+          </p:nvPr>
+        </p:nvSpPr>
+        <p:spPr>
+          <a:xfrm>
+            <a:off x="381000" y="685800"/>
+            <a:ext cx="6096000" cy="3429000"/>
+          </a:xfrm>
+          <a:custGeom>
+            <a:avLst/>
+            <a:gdLst/>
+            <a:ahLst/>
+            <a:cxnLst/>
+            <a:rect l="l" t="t" r="r" b="b"/>
+            <a:pathLst>
+              <a:path w="120000" h="120000" extrusionOk="0">
+                <a:moveTo>
+                  <a:pt x="0" y="0"/>
+                </a:moveTo>
+                <a:lnTo>
+                  <a:pt x="120000" y="0"/>
+                </a:lnTo>
+                <a:lnTo>
+                  <a:pt x="120000" y="120000"/>
+                </a:lnTo>
+                <a:lnTo>
+                  <a:pt x="0" y="120000"/>
+                </a:lnTo>
+                <a:close/>
+              </a:path>
+            </a:pathLst>
+          </a:custGeom>
+        </p:spPr>
+      </p:sp>
+      <p:sp>
+        <p:nvSpPr>
+          <p:cNvPr id="64" name="Google Shape;64;g359956e13c8_0_5:notes">
+            <a:extLst>
+              <a:ext uri="{FF2B5EF4-FFF2-40B4-BE49-F238E27FC236}">
+                <a16:creationId xmlns:a16="http://schemas.microsoft.com/office/drawing/2014/main" id="{9C906013-F764-31EC-F463-FFB54B8BC5D7}"/>
+              </a:ext>
+            </a:extLst>
+          </p:cNvPr>
+          <p:cNvSpPr txBox="1">
+            <a:spLocks noGrp="1"/>
+          </p:cNvSpPr>
+          <p:nvPr>
+            <p:ph type="body" idx="1"/>
+          </p:nvPr>
+        </p:nvSpPr>
+        <p:spPr>
+          <a:xfrm>
+            <a:off x="685800" y="4343400"/>
+            <a:ext cx="5486400" cy="4114800"/>
+          </a:xfrm>
+          <a:prstGeom prst="rect">
+            <a:avLst/>
+          </a:prstGeom>
+        </p:spPr>
+        <p:txBody>
+          <a:bodyPr spcFirstLastPara="1" wrap="square" lIns="91425" tIns="91425" rIns="91425" bIns="91425" anchor="t" anchorCtr="0">
+            <a:noAutofit/>
+          </a:bodyPr>
+          <a:lstStyle/>
+          <a:p>
+            <a:pPr marL="0" lvl="0" indent="0" algn="l" rtl="0">
+              <a:spcBef>
+                <a:spcPts val="0"/>
+              </a:spcBef>
+              <a:spcAft>
+                <a:spcPts val="0"/>
+              </a:spcAft>
+              <a:buNone/>
+            </a:pPr>
+            <a:endParaRPr/>
+          </a:p>
+        </p:txBody>
+      </p:sp>
+    </p:spTree>
+    <p:extLst>
+      <p:ext uri="{BB962C8B-B14F-4D97-AF65-F5344CB8AC3E}">
+        <p14:creationId xmlns:p14="http://schemas.microsoft.com/office/powerpoint/2010/main" val="1616506532"/>
+      </p:ext>
+    </p:extLst>
+  </p:cSld>
+  <p:clrMapOvr>
+    <a:masterClrMapping/>
+  </p:clrMapOvr>
+</p:notes>
+</file>
+
+<file path=ppt/notesSlides/notesSlide14.xml><?xml version="1.0" encoding="utf-8"?>
+<p:notes xmlns:a="http://schemas.openxmlformats.org/drawingml/2006/main" xmlns:r="http://schemas.openxmlformats.org/officeDocument/2006/relationships" xmlns:p="http://schemas.openxmlformats.org/presentationml/2006/main" showMasterSp="0" showMasterPhAnim="0">
+  <p:cSld>
+    <p:spTree>
+      <p:nvGrpSpPr>
+        <p:cNvPr id="1" name="Shape 62">
+          <a:extLst>
+            <a:ext uri="{FF2B5EF4-FFF2-40B4-BE49-F238E27FC236}">
+              <a16:creationId xmlns:a16="http://schemas.microsoft.com/office/drawing/2014/main" id="{0A7FF4F6-A366-0D88-28B1-68D0D42C07FC}"/>
+            </a:ext>
+          </a:extLst>
+        </p:cNvPr>
+        <p:cNvGrpSpPr/>
+        <p:nvPr/>
+      </p:nvGrpSpPr>
+      <p:grpSpPr>
+        <a:xfrm>
+          <a:off x="0" y="0"/>
+          <a:ext cx="0" cy="0"/>
+          <a:chOff x="0" y="0"/>
+          <a:chExt cx="0" cy="0"/>
+        </a:xfrm>
+      </p:grpSpPr>
+      <p:sp>
+        <p:nvSpPr>
+          <p:cNvPr id="63" name="Google Shape;63;g359956e13c8_0_5:notes">
+            <a:extLst>
+              <a:ext uri="{FF2B5EF4-FFF2-40B4-BE49-F238E27FC236}">
+                <a16:creationId xmlns:a16="http://schemas.microsoft.com/office/drawing/2014/main" id="{72337A15-678A-ADD6-F47D-06477CD2AA95}"/>
+              </a:ext>
+            </a:extLst>
+          </p:cNvPr>
+          <p:cNvSpPr>
+            <a:spLocks noGrp="1" noRot="1" noChangeAspect="1"/>
+          </p:cNvSpPr>
+          <p:nvPr>
+            <p:ph type="sldImg" idx="2"/>
+          </p:nvPr>
+        </p:nvSpPr>
+        <p:spPr>
+          <a:xfrm>
+            <a:off x="381000" y="685800"/>
+            <a:ext cx="6096000" cy="3429000"/>
+          </a:xfrm>
+          <a:custGeom>
+            <a:avLst/>
+            <a:gdLst/>
+            <a:ahLst/>
+            <a:cxnLst/>
+            <a:rect l="l" t="t" r="r" b="b"/>
+            <a:pathLst>
+              <a:path w="120000" h="120000" extrusionOk="0">
+                <a:moveTo>
+                  <a:pt x="0" y="0"/>
+                </a:moveTo>
+                <a:lnTo>
+                  <a:pt x="120000" y="0"/>
+                </a:lnTo>
+                <a:lnTo>
+                  <a:pt x="120000" y="120000"/>
+                </a:lnTo>
+                <a:lnTo>
+                  <a:pt x="0" y="120000"/>
+                </a:lnTo>
+                <a:close/>
+              </a:path>
+            </a:pathLst>
+          </a:custGeom>
+        </p:spPr>
+      </p:sp>
+      <p:sp>
+        <p:nvSpPr>
+          <p:cNvPr id="64" name="Google Shape;64;g359956e13c8_0_5:notes">
+            <a:extLst>
+              <a:ext uri="{FF2B5EF4-FFF2-40B4-BE49-F238E27FC236}">
+                <a16:creationId xmlns:a16="http://schemas.microsoft.com/office/drawing/2014/main" id="{2BAAE48E-3361-5E29-D263-8A97CE1636B2}"/>
+              </a:ext>
+            </a:extLst>
+          </p:cNvPr>
+          <p:cNvSpPr txBox="1">
+            <a:spLocks noGrp="1"/>
+          </p:cNvSpPr>
+          <p:nvPr>
+            <p:ph type="body" idx="1"/>
+          </p:nvPr>
+        </p:nvSpPr>
+        <p:spPr>
+          <a:xfrm>
+            <a:off x="685800" y="4343400"/>
+            <a:ext cx="5486400" cy="4114800"/>
+          </a:xfrm>
+          <a:prstGeom prst="rect">
+            <a:avLst/>
+          </a:prstGeom>
+        </p:spPr>
+        <p:txBody>
+          <a:bodyPr spcFirstLastPara="1" wrap="square" lIns="91425" tIns="91425" rIns="91425" bIns="91425" anchor="t" anchorCtr="0">
+            <a:noAutofit/>
+          </a:bodyPr>
+          <a:lstStyle/>
+          <a:p>
+            <a:pPr marL="0" lvl="0" indent="0" algn="l" rtl="0">
+              <a:spcBef>
+                <a:spcPts val="0"/>
+              </a:spcBef>
+              <a:spcAft>
+                <a:spcPts val="0"/>
+              </a:spcAft>
+              <a:buNone/>
+            </a:pPr>
+            <a:endParaRPr/>
+          </a:p>
+        </p:txBody>
+      </p:sp>
+    </p:spTree>
+    <p:extLst>
+      <p:ext uri="{BB962C8B-B14F-4D97-AF65-F5344CB8AC3E}">
+        <p14:creationId xmlns:p14="http://schemas.microsoft.com/office/powerpoint/2010/main" val="1018412350"/>
+      </p:ext>
+    </p:extLst>
+  </p:cSld>
+  <p:clrMapOvr>
+    <a:masterClrMapping/>
+  </p:clrMapOvr>
+</p:notes>
+</file>
+
+<file path=ppt/notesSlides/notesSlide15.xml><?xml version="1.0" encoding="utf-8"?>
+<p:notes xmlns:a="http://schemas.openxmlformats.org/drawingml/2006/main" xmlns:r="http://schemas.openxmlformats.org/officeDocument/2006/relationships" xmlns:p="http://schemas.openxmlformats.org/presentationml/2006/main" showMasterSp="0" showMasterPhAnim="0">
+  <p:cSld>
+    <p:spTree>
+      <p:nvGrpSpPr>
+        <p:cNvPr id="1" name="Shape 69"/>
+        <p:cNvGrpSpPr/>
+        <p:nvPr/>
+      </p:nvGrpSpPr>
+      <p:grpSpPr>
+        <a:xfrm>
+          <a:off x="0" y="0"/>
+          <a:ext cx="0" cy="0"/>
+          <a:chOff x="0" y="0"/>
+          <a:chExt cx="0" cy="0"/>
+        </a:xfrm>
+      </p:grpSpPr>
+      <p:sp>
+        <p:nvSpPr>
+          <p:cNvPr id="70" name="Google Shape;70;g359956e13c8_0_11:notes"/>
+          <p:cNvSpPr>
+            <a:spLocks noGrp="1" noRot="1" noChangeAspect="1"/>
+          </p:cNvSpPr>
+          <p:nvPr>
+            <p:ph type="sldImg" idx="2"/>
+          </p:nvPr>
+        </p:nvSpPr>
+        <p:spPr>
+          <a:xfrm>
+            <a:off x="381000" y="685800"/>
+            <a:ext cx="6096000" cy="3429000"/>
+          </a:xfrm>
+          <a:custGeom>
+            <a:avLst/>
+            <a:gdLst/>
+            <a:ahLst/>
+            <a:cxnLst/>
+            <a:rect l="l" t="t" r="r" b="b"/>
+            <a:pathLst>
+              <a:path w="120000" h="120000" extrusionOk="0">
+                <a:moveTo>
+                  <a:pt x="0" y="0"/>
+                </a:moveTo>
+                <a:lnTo>
+                  <a:pt x="120000" y="0"/>
+                </a:lnTo>
+                <a:lnTo>
+                  <a:pt x="120000" y="120000"/>
+                </a:lnTo>
+                <a:lnTo>
+                  <a:pt x="0" y="120000"/>
+                </a:lnTo>
+                <a:close/>
+              </a:path>
+            </a:pathLst>
+          </a:custGeom>
+        </p:spPr>
+      </p:sp>
+      <p:sp>
+        <p:nvSpPr>
+          <p:cNvPr id="71" name="Google Shape;71;g359956e13c8_0_11:notes"/>
+          <p:cNvSpPr txBox="1">
+            <a:spLocks noGrp="1"/>
+          </p:cNvSpPr>
+          <p:nvPr>
+            <p:ph type="body" idx="1"/>
+          </p:nvPr>
+        </p:nvSpPr>
+        <p:spPr>
+          <a:xfrm>
+            <a:off x="685800" y="4343400"/>
+            <a:ext cx="5486400" cy="4114800"/>
+          </a:xfrm>
+          <a:prstGeom prst="rect">
+            <a:avLst/>
+          </a:prstGeom>
+        </p:spPr>
+        <p:txBody>
+          <a:bodyPr spcFirstLastPara="1" wrap="square" lIns="91425" tIns="91425" rIns="91425" bIns="91425" anchor="t" anchorCtr="0">
+            <a:noAutofit/>
+          </a:bodyPr>
+          <a:lstStyle/>
+          <a:p>
+            <a:pPr marL="0" lvl="0" indent="0" algn="l" rtl="0">
+              <a:spcBef>
+                <a:spcPts val="0"/>
+              </a:spcBef>
+              <a:spcAft>
+                <a:spcPts val="0"/>
+              </a:spcAft>
+              <a:buNone/>
+            </a:pPr>
+            <a:endParaRPr/>
+          </a:p>
+        </p:txBody>
+      </p:sp>
+    </p:spTree>
+  </p:cSld>
+  <p:clrMapOvr>
+    <a:masterClrMapping/>
+  </p:clrMapOvr>
+</p:notes>
+</file>
+
 <file path=ppt/notesSlides/notesSlide2.xml><?xml version="1.0" encoding="utf-8"?>
 <p:notes xmlns:a="http://schemas.openxmlformats.org/drawingml/2006/main" xmlns:r="http://schemas.openxmlformats.org/officeDocument/2006/relationships" xmlns:p="http://schemas.openxmlformats.org/presentationml/2006/main" showMasterSp="0" showMasterPhAnim="0">
   <p:cSld>
@@ -916,7 +1667,13 @@
   <p:cSld>
     <p:spTree>
       <p:nvGrpSpPr>
-        <p:cNvPr id="1" name="Shape 69"/>
+        <p:cNvPr id="1" name="Shape 62">
+          <a:extLst>
+            <a:ext uri="{FF2B5EF4-FFF2-40B4-BE49-F238E27FC236}">
+              <a16:creationId xmlns:a16="http://schemas.microsoft.com/office/drawing/2014/main" id="{0EBA3C5C-0826-4809-1C7B-84EF24980D90}"/>
+            </a:ext>
+          </a:extLst>
+        </p:cNvPr>
         <p:cNvGrpSpPr/>
         <p:nvPr/>
       </p:nvGrpSpPr>
@@ -930,7 +1687,13 @@
       </p:grpSpPr>
       <p:sp>
         <p:nvSpPr>
-          <p:cNvPr id="70" name="Google Shape;70;g359956e13c8_0_11:notes"/>
+          <p:cNvPr id="63" name="Google Shape;63;g359956e13c8_0_5:notes">
+            <a:extLst>
+              <a:ext uri="{FF2B5EF4-FFF2-40B4-BE49-F238E27FC236}">
+                <a16:creationId xmlns:a16="http://schemas.microsoft.com/office/drawing/2014/main" id="{F348469C-99E4-B52B-BCDC-F8C2AF5C86F7}"/>
+              </a:ext>
+            </a:extLst>
+          </p:cNvPr>
           <p:cNvSpPr>
             <a:spLocks noGrp="1" noRot="1" noChangeAspect="1"/>
           </p:cNvSpPr>
@@ -971,7 +1734,13 @@
       </p:sp>
       <p:sp>
         <p:nvSpPr>
-          <p:cNvPr id="71" name="Google Shape;71;g359956e13c8_0_11:notes"/>
+          <p:cNvPr id="64" name="Google Shape;64;g359956e13c8_0_5:notes">
+            <a:extLst>
+              <a:ext uri="{FF2B5EF4-FFF2-40B4-BE49-F238E27FC236}">
+                <a16:creationId xmlns:a16="http://schemas.microsoft.com/office/drawing/2014/main" id="{BB0BE72E-CB1C-4DF3-6A32-9A5C0488FFD0}"/>
+              </a:ext>
+            </a:extLst>
+          </p:cNvPr>
           <p:cNvSpPr txBox="1">
             <a:spLocks noGrp="1"/>
           </p:cNvSpPr>
@@ -1008,6 +1777,773 @@
         </p:txBody>
       </p:sp>
     </p:spTree>
+    <p:extLst>
+      <p:ext uri="{BB962C8B-B14F-4D97-AF65-F5344CB8AC3E}">
+        <p14:creationId xmlns:p14="http://schemas.microsoft.com/office/powerpoint/2010/main" val="485946182"/>
+      </p:ext>
+    </p:extLst>
+  </p:cSld>
+  <p:clrMapOvr>
+    <a:masterClrMapping/>
+  </p:clrMapOvr>
+</p:notes>
+</file>
+
+<file path=ppt/notesSlides/notesSlide4.xml><?xml version="1.0" encoding="utf-8"?>
+<p:notes xmlns:a="http://schemas.openxmlformats.org/drawingml/2006/main" xmlns:r="http://schemas.openxmlformats.org/officeDocument/2006/relationships" xmlns:p="http://schemas.openxmlformats.org/presentationml/2006/main" showMasterSp="0" showMasterPhAnim="0">
+  <p:cSld>
+    <p:spTree>
+      <p:nvGrpSpPr>
+        <p:cNvPr id="1" name="Shape 62">
+          <a:extLst>
+            <a:ext uri="{FF2B5EF4-FFF2-40B4-BE49-F238E27FC236}">
+              <a16:creationId xmlns:a16="http://schemas.microsoft.com/office/drawing/2014/main" id="{DE284D1A-62E0-DBCC-7234-D5DE501990D0}"/>
+            </a:ext>
+          </a:extLst>
+        </p:cNvPr>
+        <p:cNvGrpSpPr/>
+        <p:nvPr/>
+      </p:nvGrpSpPr>
+      <p:grpSpPr>
+        <a:xfrm>
+          <a:off x="0" y="0"/>
+          <a:ext cx="0" cy="0"/>
+          <a:chOff x="0" y="0"/>
+          <a:chExt cx="0" cy="0"/>
+        </a:xfrm>
+      </p:grpSpPr>
+      <p:sp>
+        <p:nvSpPr>
+          <p:cNvPr id="63" name="Google Shape;63;g359956e13c8_0_5:notes">
+            <a:extLst>
+              <a:ext uri="{FF2B5EF4-FFF2-40B4-BE49-F238E27FC236}">
+                <a16:creationId xmlns:a16="http://schemas.microsoft.com/office/drawing/2014/main" id="{BAB957F0-5225-6791-1413-CB1D2B31DBF8}"/>
+              </a:ext>
+            </a:extLst>
+          </p:cNvPr>
+          <p:cNvSpPr>
+            <a:spLocks noGrp="1" noRot="1" noChangeAspect="1"/>
+          </p:cNvSpPr>
+          <p:nvPr>
+            <p:ph type="sldImg" idx="2"/>
+          </p:nvPr>
+        </p:nvSpPr>
+        <p:spPr>
+          <a:xfrm>
+            <a:off x="381000" y="685800"/>
+            <a:ext cx="6096000" cy="3429000"/>
+          </a:xfrm>
+          <a:custGeom>
+            <a:avLst/>
+            <a:gdLst/>
+            <a:ahLst/>
+            <a:cxnLst/>
+            <a:rect l="l" t="t" r="r" b="b"/>
+            <a:pathLst>
+              <a:path w="120000" h="120000" extrusionOk="0">
+                <a:moveTo>
+                  <a:pt x="0" y="0"/>
+                </a:moveTo>
+                <a:lnTo>
+                  <a:pt x="120000" y="0"/>
+                </a:lnTo>
+                <a:lnTo>
+                  <a:pt x="120000" y="120000"/>
+                </a:lnTo>
+                <a:lnTo>
+                  <a:pt x="0" y="120000"/>
+                </a:lnTo>
+                <a:close/>
+              </a:path>
+            </a:pathLst>
+          </a:custGeom>
+        </p:spPr>
+      </p:sp>
+      <p:sp>
+        <p:nvSpPr>
+          <p:cNvPr id="64" name="Google Shape;64;g359956e13c8_0_5:notes">
+            <a:extLst>
+              <a:ext uri="{FF2B5EF4-FFF2-40B4-BE49-F238E27FC236}">
+                <a16:creationId xmlns:a16="http://schemas.microsoft.com/office/drawing/2014/main" id="{B6AA508C-5278-13DC-895F-894029A6C3C0}"/>
+              </a:ext>
+            </a:extLst>
+          </p:cNvPr>
+          <p:cNvSpPr txBox="1">
+            <a:spLocks noGrp="1"/>
+          </p:cNvSpPr>
+          <p:nvPr>
+            <p:ph type="body" idx="1"/>
+          </p:nvPr>
+        </p:nvSpPr>
+        <p:spPr>
+          <a:xfrm>
+            <a:off x="685800" y="4343400"/>
+            <a:ext cx="5486400" cy="4114800"/>
+          </a:xfrm>
+          <a:prstGeom prst="rect">
+            <a:avLst/>
+          </a:prstGeom>
+        </p:spPr>
+        <p:txBody>
+          <a:bodyPr spcFirstLastPara="1" wrap="square" lIns="91425" tIns="91425" rIns="91425" bIns="91425" anchor="t" anchorCtr="0">
+            <a:noAutofit/>
+          </a:bodyPr>
+          <a:lstStyle/>
+          <a:p>
+            <a:pPr marL="0" lvl="0" indent="0" algn="l" rtl="0">
+              <a:spcBef>
+                <a:spcPts val="0"/>
+              </a:spcBef>
+              <a:spcAft>
+                <a:spcPts val="0"/>
+              </a:spcAft>
+              <a:buNone/>
+            </a:pPr>
+            <a:endParaRPr/>
+          </a:p>
+        </p:txBody>
+      </p:sp>
+    </p:spTree>
+    <p:extLst>
+      <p:ext uri="{BB962C8B-B14F-4D97-AF65-F5344CB8AC3E}">
+        <p14:creationId xmlns:p14="http://schemas.microsoft.com/office/powerpoint/2010/main" val="1943755025"/>
+      </p:ext>
+    </p:extLst>
+  </p:cSld>
+  <p:clrMapOvr>
+    <a:masterClrMapping/>
+  </p:clrMapOvr>
+</p:notes>
+</file>
+
+<file path=ppt/notesSlides/notesSlide5.xml><?xml version="1.0" encoding="utf-8"?>
+<p:notes xmlns:a="http://schemas.openxmlformats.org/drawingml/2006/main" xmlns:r="http://schemas.openxmlformats.org/officeDocument/2006/relationships" xmlns:p="http://schemas.openxmlformats.org/presentationml/2006/main" showMasterSp="0" showMasterPhAnim="0">
+  <p:cSld>
+    <p:spTree>
+      <p:nvGrpSpPr>
+        <p:cNvPr id="1" name="Shape 62">
+          <a:extLst>
+            <a:ext uri="{FF2B5EF4-FFF2-40B4-BE49-F238E27FC236}">
+              <a16:creationId xmlns:a16="http://schemas.microsoft.com/office/drawing/2014/main" id="{8D401C26-99B9-4C57-41F3-1E6315960DAA}"/>
+            </a:ext>
+          </a:extLst>
+        </p:cNvPr>
+        <p:cNvGrpSpPr/>
+        <p:nvPr/>
+      </p:nvGrpSpPr>
+      <p:grpSpPr>
+        <a:xfrm>
+          <a:off x="0" y="0"/>
+          <a:ext cx="0" cy="0"/>
+          <a:chOff x="0" y="0"/>
+          <a:chExt cx="0" cy="0"/>
+        </a:xfrm>
+      </p:grpSpPr>
+      <p:sp>
+        <p:nvSpPr>
+          <p:cNvPr id="63" name="Google Shape;63;g359956e13c8_0_5:notes">
+            <a:extLst>
+              <a:ext uri="{FF2B5EF4-FFF2-40B4-BE49-F238E27FC236}">
+                <a16:creationId xmlns:a16="http://schemas.microsoft.com/office/drawing/2014/main" id="{FCC1B478-498C-1E53-7E62-5EF472F17C60}"/>
+              </a:ext>
+            </a:extLst>
+          </p:cNvPr>
+          <p:cNvSpPr>
+            <a:spLocks noGrp="1" noRot="1" noChangeAspect="1"/>
+          </p:cNvSpPr>
+          <p:nvPr>
+            <p:ph type="sldImg" idx="2"/>
+          </p:nvPr>
+        </p:nvSpPr>
+        <p:spPr>
+          <a:xfrm>
+            <a:off x="381000" y="685800"/>
+            <a:ext cx="6096000" cy="3429000"/>
+          </a:xfrm>
+          <a:custGeom>
+            <a:avLst/>
+            <a:gdLst/>
+            <a:ahLst/>
+            <a:cxnLst/>
+            <a:rect l="l" t="t" r="r" b="b"/>
+            <a:pathLst>
+              <a:path w="120000" h="120000" extrusionOk="0">
+                <a:moveTo>
+                  <a:pt x="0" y="0"/>
+                </a:moveTo>
+                <a:lnTo>
+                  <a:pt x="120000" y="0"/>
+                </a:lnTo>
+                <a:lnTo>
+                  <a:pt x="120000" y="120000"/>
+                </a:lnTo>
+                <a:lnTo>
+                  <a:pt x="0" y="120000"/>
+                </a:lnTo>
+                <a:close/>
+              </a:path>
+            </a:pathLst>
+          </a:custGeom>
+        </p:spPr>
+      </p:sp>
+      <p:sp>
+        <p:nvSpPr>
+          <p:cNvPr id="64" name="Google Shape;64;g359956e13c8_0_5:notes">
+            <a:extLst>
+              <a:ext uri="{FF2B5EF4-FFF2-40B4-BE49-F238E27FC236}">
+                <a16:creationId xmlns:a16="http://schemas.microsoft.com/office/drawing/2014/main" id="{65AF07AE-0081-A9CC-0D25-BFC0286B3259}"/>
+              </a:ext>
+            </a:extLst>
+          </p:cNvPr>
+          <p:cNvSpPr txBox="1">
+            <a:spLocks noGrp="1"/>
+          </p:cNvSpPr>
+          <p:nvPr>
+            <p:ph type="body" idx="1"/>
+          </p:nvPr>
+        </p:nvSpPr>
+        <p:spPr>
+          <a:xfrm>
+            <a:off x="685800" y="4343400"/>
+            <a:ext cx="5486400" cy="4114800"/>
+          </a:xfrm>
+          <a:prstGeom prst="rect">
+            <a:avLst/>
+          </a:prstGeom>
+        </p:spPr>
+        <p:txBody>
+          <a:bodyPr spcFirstLastPara="1" wrap="square" lIns="91425" tIns="91425" rIns="91425" bIns="91425" anchor="t" anchorCtr="0">
+            <a:noAutofit/>
+          </a:bodyPr>
+          <a:lstStyle/>
+          <a:p>
+            <a:pPr marL="0" lvl="0" indent="0" algn="l" rtl="0">
+              <a:spcBef>
+                <a:spcPts val="0"/>
+              </a:spcBef>
+              <a:spcAft>
+                <a:spcPts val="0"/>
+              </a:spcAft>
+              <a:buNone/>
+            </a:pPr>
+            <a:endParaRPr/>
+          </a:p>
+        </p:txBody>
+      </p:sp>
+    </p:spTree>
+    <p:extLst>
+      <p:ext uri="{BB962C8B-B14F-4D97-AF65-F5344CB8AC3E}">
+        <p14:creationId xmlns:p14="http://schemas.microsoft.com/office/powerpoint/2010/main" val="2205316297"/>
+      </p:ext>
+    </p:extLst>
+  </p:cSld>
+  <p:clrMapOvr>
+    <a:masterClrMapping/>
+  </p:clrMapOvr>
+</p:notes>
+</file>
+
+<file path=ppt/notesSlides/notesSlide6.xml><?xml version="1.0" encoding="utf-8"?>
+<p:notes xmlns:a="http://schemas.openxmlformats.org/drawingml/2006/main" xmlns:r="http://schemas.openxmlformats.org/officeDocument/2006/relationships" xmlns:p="http://schemas.openxmlformats.org/presentationml/2006/main" showMasterSp="0" showMasterPhAnim="0">
+  <p:cSld>
+    <p:spTree>
+      <p:nvGrpSpPr>
+        <p:cNvPr id="1" name="Shape 62">
+          <a:extLst>
+            <a:ext uri="{FF2B5EF4-FFF2-40B4-BE49-F238E27FC236}">
+              <a16:creationId xmlns:a16="http://schemas.microsoft.com/office/drawing/2014/main" id="{4B062785-C962-7269-5CC4-37033B826849}"/>
+            </a:ext>
+          </a:extLst>
+        </p:cNvPr>
+        <p:cNvGrpSpPr/>
+        <p:nvPr/>
+      </p:nvGrpSpPr>
+      <p:grpSpPr>
+        <a:xfrm>
+          <a:off x="0" y="0"/>
+          <a:ext cx="0" cy="0"/>
+          <a:chOff x="0" y="0"/>
+          <a:chExt cx="0" cy="0"/>
+        </a:xfrm>
+      </p:grpSpPr>
+      <p:sp>
+        <p:nvSpPr>
+          <p:cNvPr id="63" name="Google Shape;63;g359956e13c8_0_5:notes">
+            <a:extLst>
+              <a:ext uri="{FF2B5EF4-FFF2-40B4-BE49-F238E27FC236}">
+                <a16:creationId xmlns:a16="http://schemas.microsoft.com/office/drawing/2014/main" id="{B766D11F-2A5C-2BF2-AAAB-30C20DB47C6B}"/>
+              </a:ext>
+            </a:extLst>
+          </p:cNvPr>
+          <p:cNvSpPr>
+            <a:spLocks noGrp="1" noRot="1" noChangeAspect="1"/>
+          </p:cNvSpPr>
+          <p:nvPr>
+            <p:ph type="sldImg" idx="2"/>
+          </p:nvPr>
+        </p:nvSpPr>
+        <p:spPr>
+          <a:xfrm>
+            <a:off x="381000" y="685800"/>
+            <a:ext cx="6096000" cy="3429000"/>
+          </a:xfrm>
+          <a:custGeom>
+            <a:avLst/>
+            <a:gdLst/>
+            <a:ahLst/>
+            <a:cxnLst/>
+            <a:rect l="l" t="t" r="r" b="b"/>
+            <a:pathLst>
+              <a:path w="120000" h="120000" extrusionOk="0">
+                <a:moveTo>
+                  <a:pt x="0" y="0"/>
+                </a:moveTo>
+                <a:lnTo>
+                  <a:pt x="120000" y="0"/>
+                </a:lnTo>
+                <a:lnTo>
+                  <a:pt x="120000" y="120000"/>
+                </a:lnTo>
+                <a:lnTo>
+                  <a:pt x="0" y="120000"/>
+                </a:lnTo>
+                <a:close/>
+              </a:path>
+            </a:pathLst>
+          </a:custGeom>
+        </p:spPr>
+      </p:sp>
+      <p:sp>
+        <p:nvSpPr>
+          <p:cNvPr id="64" name="Google Shape;64;g359956e13c8_0_5:notes">
+            <a:extLst>
+              <a:ext uri="{FF2B5EF4-FFF2-40B4-BE49-F238E27FC236}">
+                <a16:creationId xmlns:a16="http://schemas.microsoft.com/office/drawing/2014/main" id="{B2853CED-A04C-A867-5202-ABDF3CD1FEE5}"/>
+              </a:ext>
+            </a:extLst>
+          </p:cNvPr>
+          <p:cNvSpPr txBox="1">
+            <a:spLocks noGrp="1"/>
+          </p:cNvSpPr>
+          <p:nvPr>
+            <p:ph type="body" idx="1"/>
+          </p:nvPr>
+        </p:nvSpPr>
+        <p:spPr>
+          <a:xfrm>
+            <a:off x="685800" y="4343400"/>
+            <a:ext cx="5486400" cy="4114800"/>
+          </a:xfrm>
+          <a:prstGeom prst="rect">
+            <a:avLst/>
+          </a:prstGeom>
+        </p:spPr>
+        <p:txBody>
+          <a:bodyPr spcFirstLastPara="1" wrap="square" lIns="91425" tIns="91425" rIns="91425" bIns="91425" anchor="t" anchorCtr="0">
+            <a:noAutofit/>
+          </a:bodyPr>
+          <a:lstStyle/>
+          <a:p>
+            <a:pPr marL="0" lvl="0" indent="0" algn="l" rtl="0">
+              <a:spcBef>
+                <a:spcPts val="0"/>
+              </a:spcBef>
+              <a:spcAft>
+                <a:spcPts val="0"/>
+              </a:spcAft>
+              <a:buNone/>
+            </a:pPr>
+            <a:endParaRPr/>
+          </a:p>
+        </p:txBody>
+      </p:sp>
+    </p:spTree>
+    <p:extLst>
+      <p:ext uri="{BB962C8B-B14F-4D97-AF65-F5344CB8AC3E}">
+        <p14:creationId xmlns:p14="http://schemas.microsoft.com/office/powerpoint/2010/main" val="1228098733"/>
+      </p:ext>
+    </p:extLst>
+  </p:cSld>
+  <p:clrMapOvr>
+    <a:masterClrMapping/>
+  </p:clrMapOvr>
+</p:notes>
+</file>
+
+<file path=ppt/notesSlides/notesSlide7.xml><?xml version="1.0" encoding="utf-8"?>
+<p:notes xmlns:a="http://schemas.openxmlformats.org/drawingml/2006/main" xmlns:r="http://schemas.openxmlformats.org/officeDocument/2006/relationships" xmlns:p="http://schemas.openxmlformats.org/presentationml/2006/main" showMasterSp="0" showMasterPhAnim="0">
+  <p:cSld>
+    <p:spTree>
+      <p:nvGrpSpPr>
+        <p:cNvPr id="1" name="Shape 62">
+          <a:extLst>
+            <a:ext uri="{FF2B5EF4-FFF2-40B4-BE49-F238E27FC236}">
+              <a16:creationId xmlns:a16="http://schemas.microsoft.com/office/drawing/2014/main" id="{9A8F5C69-DAA9-91CF-271E-0310946CEEBD}"/>
+            </a:ext>
+          </a:extLst>
+        </p:cNvPr>
+        <p:cNvGrpSpPr/>
+        <p:nvPr/>
+      </p:nvGrpSpPr>
+      <p:grpSpPr>
+        <a:xfrm>
+          <a:off x="0" y="0"/>
+          <a:ext cx="0" cy="0"/>
+          <a:chOff x="0" y="0"/>
+          <a:chExt cx="0" cy="0"/>
+        </a:xfrm>
+      </p:grpSpPr>
+      <p:sp>
+        <p:nvSpPr>
+          <p:cNvPr id="63" name="Google Shape;63;g359956e13c8_0_5:notes">
+            <a:extLst>
+              <a:ext uri="{FF2B5EF4-FFF2-40B4-BE49-F238E27FC236}">
+                <a16:creationId xmlns:a16="http://schemas.microsoft.com/office/drawing/2014/main" id="{330F2C87-1344-5573-2B1C-612974C4E750}"/>
+              </a:ext>
+            </a:extLst>
+          </p:cNvPr>
+          <p:cNvSpPr>
+            <a:spLocks noGrp="1" noRot="1" noChangeAspect="1"/>
+          </p:cNvSpPr>
+          <p:nvPr>
+            <p:ph type="sldImg" idx="2"/>
+          </p:nvPr>
+        </p:nvSpPr>
+        <p:spPr>
+          <a:xfrm>
+            <a:off x="381000" y="685800"/>
+            <a:ext cx="6096000" cy="3429000"/>
+          </a:xfrm>
+          <a:custGeom>
+            <a:avLst/>
+            <a:gdLst/>
+            <a:ahLst/>
+            <a:cxnLst/>
+            <a:rect l="l" t="t" r="r" b="b"/>
+            <a:pathLst>
+              <a:path w="120000" h="120000" extrusionOk="0">
+                <a:moveTo>
+                  <a:pt x="0" y="0"/>
+                </a:moveTo>
+                <a:lnTo>
+                  <a:pt x="120000" y="0"/>
+                </a:lnTo>
+                <a:lnTo>
+                  <a:pt x="120000" y="120000"/>
+                </a:lnTo>
+                <a:lnTo>
+                  <a:pt x="0" y="120000"/>
+                </a:lnTo>
+                <a:close/>
+              </a:path>
+            </a:pathLst>
+          </a:custGeom>
+        </p:spPr>
+      </p:sp>
+      <p:sp>
+        <p:nvSpPr>
+          <p:cNvPr id="64" name="Google Shape;64;g359956e13c8_0_5:notes">
+            <a:extLst>
+              <a:ext uri="{FF2B5EF4-FFF2-40B4-BE49-F238E27FC236}">
+                <a16:creationId xmlns:a16="http://schemas.microsoft.com/office/drawing/2014/main" id="{4602D758-9802-2510-2D31-30919C4B2978}"/>
+              </a:ext>
+            </a:extLst>
+          </p:cNvPr>
+          <p:cNvSpPr txBox="1">
+            <a:spLocks noGrp="1"/>
+          </p:cNvSpPr>
+          <p:nvPr>
+            <p:ph type="body" idx="1"/>
+          </p:nvPr>
+        </p:nvSpPr>
+        <p:spPr>
+          <a:xfrm>
+            <a:off x="685800" y="4343400"/>
+            <a:ext cx="5486400" cy="4114800"/>
+          </a:xfrm>
+          <a:prstGeom prst="rect">
+            <a:avLst/>
+          </a:prstGeom>
+        </p:spPr>
+        <p:txBody>
+          <a:bodyPr spcFirstLastPara="1" wrap="square" lIns="91425" tIns="91425" rIns="91425" bIns="91425" anchor="t" anchorCtr="0">
+            <a:noAutofit/>
+          </a:bodyPr>
+          <a:lstStyle/>
+          <a:p>
+            <a:pPr marL="0" lvl="0" indent="0" algn="l" rtl="0">
+              <a:spcBef>
+                <a:spcPts val="0"/>
+              </a:spcBef>
+              <a:spcAft>
+                <a:spcPts val="0"/>
+              </a:spcAft>
+              <a:buNone/>
+            </a:pPr>
+            <a:endParaRPr/>
+          </a:p>
+        </p:txBody>
+      </p:sp>
+    </p:spTree>
+    <p:extLst>
+      <p:ext uri="{BB962C8B-B14F-4D97-AF65-F5344CB8AC3E}">
+        <p14:creationId xmlns:p14="http://schemas.microsoft.com/office/powerpoint/2010/main" val="2542326666"/>
+      </p:ext>
+    </p:extLst>
+  </p:cSld>
+  <p:clrMapOvr>
+    <a:masterClrMapping/>
+  </p:clrMapOvr>
+</p:notes>
+</file>
+
+<file path=ppt/notesSlides/notesSlide8.xml><?xml version="1.0" encoding="utf-8"?>
+<p:notes xmlns:a="http://schemas.openxmlformats.org/drawingml/2006/main" xmlns:r="http://schemas.openxmlformats.org/officeDocument/2006/relationships" xmlns:p="http://schemas.openxmlformats.org/presentationml/2006/main" showMasterSp="0" showMasterPhAnim="0">
+  <p:cSld>
+    <p:spTree>
+      <p:nvGrpSpPr>
+        <p:cNvPr id="1" name="Shape 62">
+          <a:extLst>
+            <a:ext uri="{FF2B5EF4-FFF2-40B4-BE49-F238E27FC236}">
+              <a16:creationId xmlns:a16="http://schemas.microsoft.com/office/drawing/2014/main" id="{853CAC8C-876D-989A-A3DF-A7806CEB289C}"/>
+            </a:ext>
+          </a:extLst>
+        </p:cNvPr>
+        <p:cNvGrpSpPr/>
+        <p:nvPr/>
+      </p:nvGrpSpPr>
+      <p:grpSpPr>
+        <a:xfrm>
+          <a:off x="0" y="0"/>
+          <a:ext cx="0" cy="0"/>
+          <a:chOff x="0" y="0"/>
+          <a:chExt cx="0" cy="0"/>
+        </a:xfrm>
+      </p:grpSpPr>
+      <p:sp>
+        <p:nvSpPr>
+          <p:cNvPr id="63" name="Google Shape;63;g359956e13c8_0_5:notes">
+            <a:extLst>
+              <a:ext uri="{FF2B5EF4-FFF2-40B4-BE49-F238E27FC236}">
+                <a16:creationId xmlns:a16="http://schemas.microsoft.com/office/drawing/2014/main" id="{A6968ABC-2222-55BE-CB37-78EEA282F980}"/>
+              </a:ext>
+            </a:extLst>
+          </p:cNvPr>
+          <p:cNvSpPr>
+            <a:spLocks noGrp="1" noRot="1" noChangeAspect="1"/>
+          </p:cNvSpPr>
+          <p:nvPr>
+            <p:ph type="sldImg" idx="2"/>
+          </p:nvPr>
+        </p:nvSpPr>
+        <p:spPr>
+          <a:xfrm>
+            <a:off x="381000" y="685800"/>
+            <a:ext cx="6096000" cy="3429000"/>
+          </a:xfrm>
+          <a:custGeom>
+            <a:avLst/>
+            <a:gdLst/>
+            <a:ahLst/>
+            <a:cxnLst/>
+            <a:rect l="l" t="t" r="r" b="b"/>
+            <a:pathLst>
+              <a:path w="120000" h="120000" extrusionOk="0">
+                <a:moveTo>
+                  <a:pt x="0" y="0"/>
+                </a:moveTo>
+                <a:lnTo>
+                  <a:pt x="120000" y="0"/>
+                </a:lnTo>
+                <a:lnTo>
+                  <a:pt x="120000" y="120000"/>
+                </a:lnTo>
+                <a:lnTo>
+                  <a:pt x="0" y="120000"/>
+                </a:lnTo>
+                <a:close/>
+              </a:path>
+            </a:pathLst>
+          </a:custGeom>
+        </p:spPr>
+      </p:sp>
+      <p:sp>
+        <p:nvSpPr>
+          <p:cNvPr id="64" name="Google Shape;64;g359956e13c8_0_5:notes">
+            <a:extLst>
+              <a:ext uri="{FF2B5EF4-FFF2-40B4-BE49-F238E27FC236}">
+                <a16:creationId xmlns:a16="http://schemas.microsoft.com/office/drawing/2014/main" id="{0FAE89EA-B919-5525-C172-4B2D8AD41EDC}"/>
+              </a:ext>
+            </a:extLst>
+          </p:cNvPr>
+          <p:cNvSpPr txBox="1">
+            <a:spLocks noGrp="1"/>
+          </p:cNvSpPr>
+          <p:nvPr>
+            <p:ph type="body" idx="1"/>
+          </p:nvPr>
+        </p:nvSpPr>
+        <p:spPr>
+          <a:xfrm>
+            <a:off x="685800" y="4343400"/>
+            <a:ext cx="5486400" cy="4114800"/>
+          </a:xfrm>
+          <a:prstGeom prst="rect">
+            <a:avLst/>
+          </a:prstGeom>
+        </p:spPr>
+        <p:txBody>
+          <a:bodyPr spcFirstLastPara="1" wrap="square" lIns="91425" tIns="91425" rIns="91425" bIns="91425" anchor="t" anchorCtr="0">
+            <a:noAutofit/>
+          </a:bodyPr>
+          <a:lstStyle/>
+          <a:p>
+            <a:pPr marL="0" lvl="0" indent="0" algn="l" rtl="0">
+              <a:spcBef>
+                <a:spcPts val="0"/>
+              </a:spcBef>
+              <a:spcAft>
+                <a:spcPts val="0"/>
+              </a:spcAft>
+              <a:buNone/>
+            </a:pPr>
+            <a:endParaRPr/>
+          </a:p>
+        </p:txBody>
+      </p:sp>
+    </p:spTree>
+    <p:extLst>
+      <p:ext uri="{BB962C8B-B14F-4D97-AF65-F5344CB8AC3E}">
+        <p14:creationId xmlns:p14="http://schemas.microsoft.com/office/powerpoint/2010/main" val="570827785"/>
+      </p:ext>
+    </p:extLst>
+  </p:cSld>
+  <p:clrMapOvr>
+    <a:masterClrMapping/>
+  </p:clrMapOvr>
+</p:notes>
+</file>
+
+<file path=ppt/notesSlides/notesSlide9.xml><?xml version="1.0" encoding="utf-8"?>
+<p:notes xmlns:a="http://schemas.openxmlformats.org/drawingml/2006/main" xmlns:r="http://schemas.openxmlformats.org/officeDocument/2006/relationships" xmlns:p="http://schemas.openxmlformats.org/presentationml/2006/main" showMasterSp="0" showMasterPhAnim="0">
+  <p:cSld>
+    <p:spTree>
+      <p:nvGrpSpPr>
+        <p:cNvPr id="1" name="Shape 62">
+          <a:extLst>
+            <a:ext uri="{FF2B5EF4-FFF2-40B4-BE49-F238E27FC236}">
+              <a16:creationId xmlns:a16="http://schemas.microsoft.com/office/drawing/2014/main" id="{19FFE525-B9C3-85BF-BEF2-605997922F4D}"/>
+            </a:ext>
+          </a:extLst>
+        </p:cNvPr>
+        <p:cNvGrpSpPr/>
+        <p:nvPr/>
+      </p:nvGrpSpPr>
+      <p:grpSpPr>
+        <a:xfrm>
+          <a:off x="0" y="0"/>
+          <a:ext cx="0" cy="0"/>
+          <a:chOff x="0" y="0"/>
+          <a:chExt cx="0" cy="0"/>
+        </a:xfrm>
+      </p:grpSpPr>
+      <p:sp>
+        <p:nvSpPr>
+          <p:cNvPr id="63" name="Google Shape;63;g359956e13c8_0_5:notes">
+            <a:extLst>
+              <a:ext uri="{FF2B5EF4-FFF2-40B4-BE49-F238E27FC236}">
+                <a16:creationId xmlns:a16="http://schemas.microsoft.com/office/drawing/2014/main" id="{19919787-6D23-5A50-D70D-37EF26624F6B}"/>
+              </a:ext>
+            </a:extLst>
+          </p:cNvPr>
+          <p:cNvSpPr>
+            <a:spLocks noGrp="1" noRot="1" noChangeAspect="1"/>
+          </p:cNvSpPr>
+          <p:nvPr>
+            <p:ph type="sldImg" idx="2"/>
+          </p:nvPr>
+        </p:nvSpPr>
+        <p:spPr>
+          <a:xfrm>
+            <a:off x="381000" y="685800"/>
+            <a:ext cx="6096000" cy="3429000"/>
+          </a:xfrm>
+          <a:custGeom>
+            <a:avLst/>
+            <a:gdLst/>
+            <a:ahLst/>
+            <a:cxnLst/>
+            <a:rect l="l" t="t" r="r" b="b"/>
+            <a:pathLst>
+              <a:path w="120000" h="120000" extrusionOk="0">
+                <a:moveTo>
+                  <a:pt x="0" y="0"/>
+                </a:moveTo>
+                <a:lnTo>
+                  <a:pt x="120000" y="0"/>
+                </a:lnTo>
+                <a:lnTo>
+                  <a:pt x="120000" y="120000"/>
+                </a:lnTo>
+                <a:lnTo>
+                  <a:pt x="0" y="120000"/>
+                </a:lnTo>
+                <a:close/>
+              </a:path>
+            </a:pathLst>
+          </a:custGeom>
+        </p:spPr>
+      </p:sp>
+      <p:sp>
+        <p:nvSpPr>
+          <p:cNvPr id="64" name="Google Shape;64;g359956e13c8_0_5:notes">
+            <a:extLst>
+              <a:ext uri="{FF2B5EF4-FFF2-40B4-BE49-F238E27FC236}">
+                <a16:creationId xmlns:a16="http://schemas.microsoft.com/office/drawing/2014/main" id="{2BF22B23-C2A7-6B5C-3BA3-39EABE3C6807}"/>
+              </a:ext>
+            </a:extLst>
+          </p:cNvPr>
+          <p:cNvSpPr txBox="1">
+            <a:spLocks noGrp="1"/>
+          </p:cNvSpPr>
+          <p:nvPr>
+            <p:ph type="body" idx="1"/>
+          </p:nvPr>
+        </p:nvSpPr>
+        <p:spPr>
+          <a:xfrm>
+            <a:off x="685800" y="4343400"/>
+            <a:ext cx="5486400" cy="4114800"/>
+          </a:xfrm>
+          <a:prstGeom prst="rect">
+            <a:avLst/>
+          </a:prstGeom>
+        </p:spPr>
+        <p:txBody>
+          <a:bodyPr spcFirstLastPara="1" wrap="square" lIns="91425" tIns="91425" rIns="91425" bIns="91425" anchor="t" anchorCtr="0">
+            <a:noAutofit/>
+          </a:bodyPr>
+          <a:lstStyle/>
+          <a:p>
+            <a:pPr marL="0" lvl="0" indent="0" algn="l" rtl="0">
+              <a:spcBef>
+                <a:spcPts val="0"/>
+              </a:spcBef>
+              <a:spcAft>
+                <a:spcPts val="0"/>
+              </a:spcAft>
+              <a:buNone/>
+            </a:pPr>
+            <a:endParaRPr/>
+          </a:p>
+        </p:txBody>
+      </p:sp>
+    </p:spTree>
+    <p:extLst>
+      <p:ext uri="{BB962C8B-B14F-4D97-AF65-F5344CB8AC3E}">
+        <p14:creationId xmlns:p14="http://schemas.microsoft.com/office/powerpoint/2010/main" val="4025963139"/>
+      </p:ext>
+    </p:extLst>
   </p:cSld>
   <p:clrMapOvr>
     <a:masterClrMapping/>
@@ -5513,6 +7049,454 @@
 </p:sld>
 </file>
 
+<file path=ppt/slides/slide10.xml><?xml version="1.0" encoding="utf-8"?>
+<p:sld xmlns:a="http://schemas.openxmlformats.org/drawingml/2006/main" xmlns:r="http://schemas.openxmlformats.org/officeDocument/2006/relationships" xmlns:p="http://schemas.openxmlformats.org/presentationml/2006/main">
+  <p:cSld>
+    <p:bg>
+      <p:bgPr>
+        <a:blipFill>
+          <a:blip r:embed="rId3"/>
+          <a:stretch>
+            <a:fillRect/>
+          </a:stretch>
+        </a:blipFill>
+        <a:effectLst/>
+      </p:bgPr>
+    </p:bg>
+    <p:spTree>
+      <p:nvGrpSpPr>
+        <p:cNvPr id="1" name="Shape 65">
+          <a:extLst>
+            <a:ext uri="{FF2B5EF4-FFF2-40B4-BE49-F238E27FC236}">
+              <a16:creationId xmlns:a16="http://schemas.microsoft.com/office/drawing/2014/main" id="{A12EBA9A-DA19-29D5-0B95-A306FB0F36C4}"/>
+            </a:ext>
+          </a:extLst>
+        </p:cNvPr>
+        <p:cNvGrpSpPr/>
+        <p:nvPr/>
+      </p:nvGrpSpPr>
+      <p:grpSpPr>
+        <a:xfrm>
+          <a:off x="0" y="0"/>
+          <a:ext cx="0" cy="0"/>
+          <a:chOff x="0" y="0"/>
+          <a:chExt cx="0" cy="0"/>
+        </a:xfrm>
+      </p:grpSpPr>
+      <p:sp>
+        <p:nvSpPr>
+          <p:cNvPr id="5" name="Title 4">
+            <a:extLst>
+              <a:ext uri="{FF2B5EF4-FFF2-40B4-BE49-F238E27FC236}">
+                <a16:creationId xmlns:a16="http://schemas.microsoft.com/office/drawing/2014/main" id="{94F76BFB-1D1A-8727-0F67-89A13F3A1B67}"/>
+              </a:ext>
+            </a:extLst>
+          </p:cNvPr>
+          <p:cNvSpPr>
+            <a:spLocks noGrp="1"/>
+          </p:cNvSpPr>
+          <p:nvPr>
+            <p:ph type="title"/>
+          </p:nvPr>
+        </p:nvSpPr>
+        <p:spPr/>
+        <p:txBody>
+          <a:bodyPr>
+            <a:normAutofit fontScale="90000"/>
+          </a:bodyPr>
+          <a:lstStyle/>
+          <a:p>
+            <a:endParaRPr lang="en-ID"/>
+          </a:p>
+        </p:txBody>
+      </p:sp>
+    </p:spTree>
+    <p:extLst>
+      <p:ext uri="{BB962C8B-B14F-4D97-AF65-F5344CB8AC3E}">
+        <p14:creationId xmlns:p14="http://schemas.microsoft.com/office/powerpoint/2010/main" val="3265166932"/>
+      </p:ext>
+    </p:extLst>
+  </p:cSld>
+  <p:clrMapOvr>
+    <a:masterClrMapping/>
+  </p:clrMapOvr>
+</p:sld>
+</file>
+
+<file path=ppt/slides/slide11.xml><?xml version="1.0" encoding="utf-8"?>
+<p:sld xmlns:a="http://schemas.openxmlformats.org/drawingml/2006/main" xmlns:r="http://schemas.openxmlformats.org/officeDocument/2006/relationships" xmlns:p="http://schemas.openxmlformats.org/presentationml/2006/main">
+  <p:cSld>
+    <p:bg>
+      <p:bgPr>
+        <a:blipFill>
+          <a:blip r:embed="rId3"/>
+          <a:stretch>
+            <a:fillRect/>
+          </a:stretch>
+        </a:blipFill>
+        <a:effectLst/>
+      </p:bgPr>
+    </p:bg>
+    <p:spTree>
+      <p:nvGrpSpPr>
+        <p:cNvPr id="1" name="Shape 65">
+          <a:extLst>
+            <a:ext uri="{FF2B5EF4-FFF2-40B4-BE49-F238E27FC236}">
+              <a16:creationId xmlns:a16="http://schemas.microsoft.com/office/drawing/2014/main" id="{D48E1645-063B-09BC-F293-FED7ECC0BF9F}"/>
+            </a:ext>
+          </a:extLst>
+        </p:cNvPr>
+        <p:cNvGrpSpPr/>
+        <p:nvPr/>
+      </p:nvGrpSpPr>
+      <p:grpSpPr>
+        <a:xfrm>
+          <a:off x="0" y="0"/>
+          <a:ext cx="0" cy="0"/>
+          <a:chOff x="0" y="0"/>
+          <a:chExt cx="0" cy="0"/>
+        </a:xfrm>
+      </p:grpSpPr>
+      <p:sp>
+        <p:nvSpPr>
+          <p:cNvPr id="5" name="Title 4">
+            <a:extLst>
+              <a:ext uri="{FF2B5EF4-FFF2-40B4-BE49-F238E27FC236}">
+                <a16:creationId xmlns:a16="http://schemas.microsoft.com/office/drawing/2014/main" id="{097C93F1-EBE7-EB4E-74C1-58E38670B0A3}"/>
+              </a:ext>
+            </a:extLst>
+          </p:cNvPr>
+          <p:cNvSpPr>
+            <a:spLocks noGrp="1"/>
+          </p:cNvSpPr>
+          <p:nvPr>
+            <p:ph type="title"/>
+          </p:nvPr>
+        </p:nvSpPr>
+        <p:spPr/>
+        <p:txBody>
+          <a:bodyPr>
+            <a:normAutofit fontScale="90000"/>
+          </a:bodyPr>
+          <a:lstStyle/>
+          <a:p>
+            <a:endParaRPr lang="en-ID"/>
+          </a:p>
+        </p:txBody>
+      </p:sp>
+    </p:spTree>
+    <p:extLst>
+      <p:ext uri="{BB962C8B-B14F-4D97-AF65-F5344CB8AC3E}">
+        <p14:creationId xmlns:p14="http://schemas.microsoft.com/office/powerpoint/2010/main" val="1589716599"/>
+      </p:ext>
+    </p:extLst>
+  </p:cSld>
+  <p:clrMapOvr>
+    <a:masterClrMapping/>
+  </p:clrMapOvr>
+</p:sld>
+</file>
+
+<file path=ppt/slides/slide12.xml><?xml version="1.0" encoding="utf-8"?>
+<p:sld xmlns:a="http://schemas.openxmlformats.org/drawingml/2006/main" xmlns:r="http://schemas.openxmlformats.org/officeDocument/2006/relationships" xmlns:p="http://schemas.openxmlformats.org/presentationml/2006/main">
+  <p:cSld>
+    <p:bg>
+      <p:bgPr>
+        <a:blipFill>
+          <a:blip r:embed="rId3"/>
+          <a:stretch>
+            <a:fillRect/>
+          </a:stretch>
+        </a:blipFill>
+        <a:effectLst/>
+      </p:bgPr>
+    </p:bg>
+    <p:spTree>
+      <p:nvGrpSpPr>
+        <p:cNvPr id="1" name="Shape 65">
+          <a:extLst>
+            <a:ext uri="{FF2B5EF4-FFF2-40B4-BE49-F238E27FC236}">
+              <a16:creationId xmlns:a16="http://schemas.microsoft.com/office/drawing/2014/main" id="{B191C14E-3FF4-C0CF-05AA-E8CB8025671F}"/>
+            </a:ext>
+          </a:extLst>
+        </p:cNvPr>
+        <p:cNvGrpSpPr/>
+        <p:nvPr/>
+      </p:nvGrpSpPr>
+      <p:grpSpPr>
+        <a:xfrm>
+          <a:off x="0" y="0"/>
+          <a:ext cx="0" cy="0"/>
+          <a:chOff x="0" y="0"/>
+          <a:chExt cx="0" cy="0"/>
+        </a:xfrm>
+      </p:grpSpPr>
+      <p:sp>
+        <p:nvSpPr>
+          <p:cNvPr id="5" name="Title 4">
+            <a:extLst>
+              <a:ext uri="{FF2B5EF4-FFF2-40B4-BE49-F238E27FC236}">
+                <a16:creationId xmlns:a16="http://schemas.microsoft.com/office/drawing/2014/main" id="{485FD782-D77D-A60C-62FD-E297C6800CB3}"/>
+              </a:ext>
+            </a:extLst>
+          </p:cNvPr>
+          <p:cNvSpPr>
+            <a:spLocks noGrp="1"/>
+          </p:cNvSpPr>
+          <p:nvPr>
+            <p:ph type="title"/>
+          </p:nvPr>
+        </p:nvSpPr>
+        <p:spPr/>
+        <p:txBody>
+          <a:bodyPr>
+            <a:normAutofit fontScale="90000"/>
+          </a:bodyPr>
+          <a:lstStyle/>
+          <a:p>
+            <a:endParaRPr lang="en-ID"/>
+          </a:p>
+        </p:txBody>
+      </p:sp>
+    </p:spTree>
+    <p:extLst>
+      <p:ext uri="{BB962C8B-B14F-4D97-AF65-F5344CB8AC3E}">
+        <p14:creationId xmlns:p14="http://schemas.microsoft.com/office/powerpoint/2010/main" val="1001758246"/>
+      </p:ext>
+    </p:extLst>
+  </p:cSld>
+  <p:clrMapOvr>
+    <a:masterClrMapping/>
+  </p:clrMapOvr>
+</p:sld>
+</file>
+
+<file path=ppt/slides/slide13.xml><?xml version="1.0" encoding="utf-8"?>
+<p:sld xmlns:a="http://schemas.openxmlformats.org/drawingml/2006/main" xmlns:r="http://schemas.openxmlformats.org/officeDocument/2006/relationships" xmlns:p="http://schemas.openxmlformats.org/presentationml/2006/main">
+  <p:cSld>
+    <p:bg>
+      <p:bgPr>
+        <a:blipFill>
+          <a:blip r:embed="rId3"/>
+          <a:stretch>
+            <a:fillRect/>
+          </a:stretch>
+        </a:blipFill>
+        <a:effectLst/>
+      </p:bgPr>
+    </p:bg>
+    <p:spTree>
+      <p:nvGrpSpPr>
+        <p:cNvPr id="1" name="Shape 65">
+          <a:extLst>
+            <a:ext uri="{FF2B5EF4-FFF2-40B4-BE49-F238E27FC236}">
+              <a16:creationId xmlns:a16="http://schemas.microsoft.com/office/drawing/2014/main" id="{B4942BD2-F047-0ABF-74B2-587068D80599}"/>
+            </a:ext>
+          </a:extLst>
+        </p:cNvPr>
+        <p:cNvGrpSpPr/>
+        <p:nvPr/>
+      </p:nvGrpSpPr>
+      <p:grpSpPr>
+        <a:xfrm>
+          <a:off x="0" y="0"/>
+          <a:ext cx="0" cy="0"/>
+          <a:chOff x="0" y="0"/>
+          <a:chExt cx="0" cy="0"/>
+        </a:xfrm>
+      </p:grpSpPr>
+      <p:sp>
+        <p:nvSpPr>
+          <p:cNvPr id="5" name="Title 4">
+            <a:extLst>
+              <a:ext uri="{FF2B5EF4-FFF2-40B4-BE49-F238E27FC236}">
+                <a16:creationId xmlns:a16="http://schemas.microsoft.com/office/drawing/2014/main" id="{03196CAC-51FF-4C2A-7A7E-FA3C13884E66}"/>
+              </a:ext>
+            </a:extLst>
+          </p:cNvPr>
+          <p:cNvSpPr>
+            <a:spLocks noGrp="1"/>
+          </p:cNvSpPr>
+          <p:nvPr>
+            <p:ph type="title"/>
+          </p:nvPr>
+        </p:nvSpPr>
+        <p:spPr/>
+        <p:txBody>
+          <a:bodyPr>
+            <a:normAutofit fontScale="90000"/>
+          </a:bodyPr>
+          <a:lstStyle/>
+          <a:p>
+            <a:endParaRPr lang="en-ID"/>
+          </a:p>
+        </p:txBody>
+      </p:sp>
+    </p:spTree>
+    <p:extLst>
+      <p:ext uri="{BB962C8B-B14F-4D97-AF65-F5344CB8AC3E}">
+        <p14:creationId xmlns:p14="http://schemas.microsoft.com/office/powerpoint/2010/main" val="729131376"/>
+      </p:ext>
+    </p:extLst>
+  </p:cSld>
+  <p:clrMapOvr>
+    <a:masterClrMapping/>
+  </p:clrMapOvr>
+</p:sld>
+</file>
+
+<file path=ppt/slides/slide14.xml><?xml version="1.0" encoding="utf-8"?>
+<p:sld xmlns:a="http://schemas.openxmlformats.org/drawingml/2006/main" xmlns:r="http://schemas.openxmlformats.org/officeDocument/2006/relationships" xmlns:p="http://schemas.openxmlformats.org/presentationml/2006/main">
+  <p:cSld>
+    <p:bg>
+      <p:bgPr>
+        <a:blipFill>
+          <a:blip r:embed="rId3"/>
+          <a:stretch>
+            <a:fillRect/>
+          </a:stretch>
+        </a:blipFill>
+        <a:effectLst/>
+      </p:bgPr>
+    </p:bg>
+    <p:spTree>
+      <p:nvGrpSpPr>
+        <p:cNvPr id="1" name="Shape 65">
+          <a:extLst>
+            <a:ext uri="{FF2B5EF4-FFF2-40B4-BE49-F238E27FC236}">
+              <a16:creationId xmlns:a16="http://schemas.microsoft.com/office/drawing/2014/main" id="{876BAB00-CC1D-7FB0-9F05-DB7FABBBFF59}"/>
+            </a:ext>
+          </a:extLst>
+        </p:cNvPr>
+        <p:cNvGrpSpPr/>
+        <p:nvPr/>
+      </p:nvGrpSpPr>
+      <p:grpSpPr>
+        <a:xfrm>
+          <a:off x="0" y="0"/>
+          <a:ext cx="0" cy="0"/>
+          <a:chOff x="0" y="0"/>
+          <a:chExt cx="0" cy="0"/>
+        </a:xfrm>
+      </p:grpSpPr>
+      <p:sp>
+        <p:nvSpPr>
+          <p:cNvPr id="5" name="Title 4">
+            <a:extLst>
+              <a:ext uri="{FF2B5EF4-FFF2-40B4-BE49-F238E27FC236}">
+                <a16:creationId xmlns:a16="http://schemas.microsoft.com/office/drawing/2014/main" id="{38560CC1-E48C-DADB-F5D3-B581DCCDCA58}"/>
+              </a:ext>
+            </a:extLst>
+          </p:cNvPr>
+          <p:cNvSpPr>
+            <a:spLocks noGrp="1"/>
+          </p:cNvSpPr>
+          <p:nvPr>
+            <p:ph type="title"/>
+          </p:nvPr>
+        </p:nvSpPr>
+        <p:spPr/>
+        <p:txBody>
+          <a:bodyPr>
+            <a:normAutofit fontScale="90000"/>
+          </a:bodyPr>
+          <a:lstStyle/>
+          <a:p>
+            <a:endParaRPr lang="en-ID"/>
+          </a:p>
+        </p:txBody>
+      </p:sp>
+    </p:spTree>
+    <p:extLst>
+      <p:ext uri="{BB962C8B-B14F-4D97-AF65-F5344CB8AC3E}">
+        <p14:creationId xmlns:p14="http://schemas.microsoft.com/office/powerpoint/2010/main" val="107323562"/>
+      </p:ext>
+    </p:extLst>
+  </p:cSld>
+  <p:clrMapOvr>
+    <a:masterClrMapping/>
+  </p:clrMapOvr>
+</p:sld>
+</file>
+
+<file path=ppt/slides/slide15.xml><?xml version="1.0" encoding="utf-8"?>
+<p:sld xmlns:a="http://schemas.openxmlformats.org/drawingml/2006/main" xmlns:r="http://schemas.openxmlformats.org/officeDocument/2006/relationships" xmlns:p="http://schemas.openxmlformats.org/presentationml/2006/main">
+  <p:cSld>
+    <p:bg>
+      <p:bgPr>
+        <a:blipFill>
+          <a:blip r:embed="rId3"/>
+          <a:stretch>
+            <a:fillRect/>
+          </a:stretch>
+        </a:blipFill>
+        <a:effectLst/>
+      </p:bgPr>
+    </p:bg>
+    <p:spTree>
+      <p:nvGrpSpPr>
+        <p:cNvPr id="1" name="Shape 72"/>
+        <p:cNvGrpSpPr/>
+        <p:nvPr/>
+      </p:nvGrpSpPr>
+      <p:grpSpPr>
+        <a:xfrm>
+          <a:off x="0" y="0"/>
+          <a:ext cx="0" cy="0"/>
+          <a:chOff x="0" y="0"/>
+          <a:chExt cx="0" cy="0"/>
+        </a:xfrm>
+      </p:grpSpPr>
+      <p:sp>
+        <p:nvSpPr>
+          <p:cNvPr id="73" name="Google Shape;73;p16"/>
+          <p:cNvSpPr txBox="1"/>
+          <p:nvPr/>
+        </p:nvSpPr>
+        <p:spPr>
+          <a:xfrm>
+            <a:off x="2627975" y="1138325"/>
+            <a:ext cx="6548700" cy="461700"/>
+          </a:xfrm>
+          <a:prstGeom prst="rect">
+            <a:avLst/>
+          </a:prstGeom>
+          <a:noFill/>
+          <a:ln>
+            <a:noFill/>
+          </a:ln>
+        </p:spPr>
+        <p:txBody>
+          <a:bodyPr spcFirstLastPara="1" wrap="square" lIns="91425" tIns="91425" rIns="91425" bIns="91425" anchor="t" anchorCtr="0">
+            <a:spAutoFit/>
+          </a:bodyPr>
+          <a:lstStyle/>
+          <a:p>
+            <a:pPr marL="0" lvl="0" indent="0" algn="l" rtl="0">
+              <a:spcBef>
+                <a:spcPts val="0"/>
+              </a:spcBef>
+              <a:spcAft>
+                <a:spcPts val="0"/>
+              </a:spcAft>
+              <a:buNone/>
+            </a:pPr>
+            <a:endParaRPr sz="1800">
+              <a:solidFill>
+                <a:schemeClr val="dk2"/>
+              </a:solidFill>
+            </a:endParaRPr>
+          </a:p>
+        </p:txBody>
+      </p:sp>
+    </p:spTree>
+  </p:cSld>
+  <p:clrMapOvr>
+    <a:masterClrMapping/>
+  </p:clrMapOvr>
+</p:sld>
+</file>
+
 <file path=ppt/slides/slide2.xml><?xml version="1.0" encoding="utf-8"?>
 <p:sld xmlns:a="http://schemas.openxmlformats.org/drawingml/2006/main" xmlns:r="http://schemas.openxmlformats.org/officeDocument/2006/relationships" xmlns:p="http://schemas.openxmlformats.org/presentationml/2006/main">
   <p:cSld>
@@ -5592,7 +7576,13 @@
     </p:bg>
     <p:spTree>
       <p:nvGrpSpPr>
-        <p:cNvPr id="1" name="Shape 72"/>
+        <p:cNvPr id="1" name="Shape 65">
+          <a:extLst>
+            <a:ext uri="{FF2B5EF4-FFF2-40B4-BE49-F238E27FC236}">
+              <a16:creationId xmlns:a16="http://schemas.microsoft.com/office/drawing/2014/main" id="{AB0F090A-AE11-BA71-014C-79EF5E0AF9DC}"/>
+            </a:ext>
+          </a:extLst>
+        </p:cNvPr>
         <p:cNvGrpSpPr/>
         <p:nvPr/>
       </p:nvGrpSpPr>
@@ -5606,47 +7596,481 @@
       </p:grpSpPr>
       <p:sp>
         <p:nvSpPr>
-          <p:cNvPr id="73" name="Google Shape;73;p16"/>
-          <p:cNvSpPr txBox="1"/>
-          <p:nvPr/>
+          <p:cNvPr id="5" name="Title 4">
+            <a:extLst>
+              <a:ext uri="{FF2B5EF4-FFF2-40B4-BE49-F238E27FC236}">
+                <a16:creationId xmlns:a16="http://schemas.microsoft.com/office/drawing/2014/main" id="{724D293C-6F97-D20D-F13C-40E531557CF5}"/>
+              </a:ext>
+            </a:extLst>
+          </p:cNvPr>
+          <p:cNvSpPr>
+            <a:spLocks noGrp="1"/>
+          </p:cNvSpPr>
+          <p:nvPr>
+            <p:ph type="title"/>
+          </p:nvPr>
         </p:nvSpPr>
-        <p:spPr>
-          <a:xfrm>
-            <a:off x="2627975" y="1138325"/>
-            <a:ext cx="6548700" cy="461700"/>
-          </a:xfrm>
-          <a:prstGeom prst="rect">
-            <a:avLst/>
-          </a:prstGeom>
-          <a:noFill/>
-          <a:ln>
-            <a:noFill/>
-          </a:ln>
-        </p:spPr>
+        <p:spPr/>
         <p:txBody>
-          <a:bodyPr spcFirstLastPara="1" wrap="square" lIns="91425" tIns="91425" rIns="91425" bIns="91425" anchor="t" anchorCtr="0">
-            <a:spAutoFit/>
+          <a:bodyPr>
+            <a:normAutofit fontScale="90000"/>
           </a:bodyPr>
           <a:lstStyle/>
           <a:p>
-            <a:pPr marL="0" lvl="0" indent="0" algn="l" rtl="0">
-              <a:spcBef>
-                <a:spcPts val="0"/>
-              </a:spcBef>
-              <a:spcAft>
-                <a:spcPts val="0"/>
-              </a:spcAft>
-              <a:buNone/>
-            </a:pPr>
-            <a:endParaRPr sz="1800">
-              <a:solidFill>
-                <a:schemeClr val="dk2"/>
-              </a:solidFill>
-            </a:endParaRPr>
+            <a:endParaRPr lang="en-ID"/>
           </a:p>
         </p:txBody>
       </p:sp>
     </p:spTree>
+    <p:extLst>
+      <p:ext uri="{BB962C8B-B14F-4D97-AF65-F5344CB8AC3E}">
+        <p14:creationId xmlns:p14="http://schemas.microsoft.com/office/powerpoint/2010/main" val="439507773"/>
+      </p:ext>
+    </p:extLst>
+  </p:cSld>
+  <p:clrMapOvr>
+    <a:masterClrMapping/>
+  </p:clrMapOvr>
+</p:sld>
+</file>
+
+<file path=ppt/slides/slide4.xml><?xml version="1.0" encoding="utf-8"?>
+<p:sld xmlns:a="http://schemas.openxmlformats.org/drawingml/2006/main" xmlns:r="http://schemas.openxmlformats.org/officeDocument/2006/relationships" xmlns:p="http://schemas.openxmlformats.org/presentationml/2006/main">
+  <p:cSld>
+    <p:bg>
+      <p:bgPr>
+        <a:blipFill>
+          <a:blip r:embed="rId3"/>
+          <a:stretch>
+            <a:fillRect/>
+          </a:stretch>
+        </a:blipFill>
+        <a:effectLst/>
+      </p:bgPr>
+    </p:bg>
+    <p:spTree>
+      <p:nvGrpSpPr>
+        <p:cNvPr id="1" name="Shape 65">
+          <a:extLst>
+            <a:ext uri="{FF2B5EF4-FFF2-40B4-BE49-F238E27FC236}">
+              <a16:creationId xmlns:a16="http://schemas.microsoft.com/office/drawing/2014/main" id="{BC51AF43-D872-719A-C6EA-864FDF7EA22C}"/>
+            </a:ext>
+          </a:extLst>
+        </p:cNvPr>
+        <p:cNvGrpSpPr/>
+        <p:nvPr/>
+      </p:nvGrpSpPr>
+      <p:grpSpPr>
+        <a:xfrm>
+          <a:off x="0" y="0"/>
+          <a:ext cx="0" cy="0"/>
+          <a:chOff x="0" y="0"/>
+          <a:chExt cx="0" cy="0"/>
+        </a:xfrm>
+      </p:grpSpPr>
+      <p:sp>
+        <p:nvSpPr>
+          <p:cNvPr id="5" name="Title 4">
+            <a:extLst>
+              <a:ext uri="{FF2B5EF4-FFF2-40B4-BE49-F238E27FC236}">
+                <a16:creationId xmlns:a16="http://schemas.microsoft.com/office/drawing/2014/main" id="{C8A016C2-E174-111C-A356-59D7154367C8}"/>
+              </a:ext>
+            </a:extLst>
+          </p:cNvPr>
+          <p:cNvSpPr>
+            <a:spLocks noGrp="1"/>
+          </p:cNvSpPr>
+          <p:nvPr>
+            <p:ph type="title"/>
+          </p:nvPr>
+        </p:nvSpPr>
+        <p:spPr/>
+        <p:txBody>
+          <a:bodyPr>
+            <a:normAutofit fontScale="90000"/>
+          </a:bodyPr>
+          <a:lstStyle/>
+          <a:p>
+            <a:endParaRPr lang="en-ID"/>
+          </a:p>
+        </p:txBody>
+      </p:sp>
+    </p:spTree>
+    <p:extLst>
+      <p:ext uri="{BB962C8B-B14F-4D97-AF65-F5344CB8AC3E}">
+        <p14:creationId xmlns:p14="http://schemas.microsoft.com/office/powerpoint/2010/main" val="3012474682"/>
+      </p:ext>
+    </p:extLst>
+  </p:cSld>
+  <p:clrMapOvr>
+    <a:masterClrMapping/>
+  </p:clrMapOvr>
+</p:sld>
+</file>
+
+<file path=ppt/slides/slide5.xml><?xml version="1.0" encoding="utf-8"?>
+<p:sld xmlns:a="http://schemas.openxmlformats.org/drawingml/2006/main" xmlns:r="http://schemas.openxmlformats.org/officeDocument/2006/relationships" xmlns:p="http://schemas.openxmlformats.org/presentationml/2006/main">
+  <p:cSld>
+    <p:bg>
+      <p:bgPr>
+        <a:blipFill>
+          <a:blip r:embed="rId3"/>
+          <a:stretch>
+            <a:fillRect/>
+          </a:stretch>
+        </a:blipFill>
+        <a:effectLst/>
+      </p:bgPr>
+    </p:bg>
+    <p:spTree>
+      <p:nvGrpSpPr>
+        <p:cNvPr id="1" name="Shape 65">
+          <a:extLst>
+            <a:ext uri="{FF2B5EF4-FFF2-40B4-BE49-F238E27FC236}">
+              <a16:creationId xmlns:a16="http://schemas.microsoft.com/office/drawing/2014/main" id="{8290DC83-EC4D-3586-8C2A-30BF3570C910}"/>
+            </a:ext>
+          </a:extLst>
+        </p:cNvPr>
+        <p:cNvGrpSpPr/>
+        <p:nvPr/>
+      </p:nvGrpSpPr>
+      <p:grpSpPr>
+        <a:xfrm>
+          <a:off x="0" y="0"/>
+          <a:ext cx="0" cy="0"/>
+          <a:chOff x="0" y="0"/>
+          <a:chExt cx="0" cy="0"/>
+        </a:xfrm>
+      </p:grpSpPr>
+      <p:sp>
+        <p:nvSpPr>
+          <p:cNvPr id="5" name="Title 4">
+            <a:extLst>
+              <a:ext uri="{FF2B5EF4-FFF2-40B4-BE49-F238E27FC236}">
+                <a16:creationId xmlns:a16="http://schemas.microsoft.com/office/drawing/2014/main" id="{E196858A-4023-B6DB-00AB-50C0755CDF35}"/>
+              </a:ext>
+            </a:extLst>
+          </p:cNvPr>
+          <p:cNvSpPr>
+            <a:spLocks noGrp="1"/>
+          </p:cNvSpPr>
+          <p:nvPr>
+            <p:ph type="title"/>
+          </p:nvPr>
+        </p:nvSpPr>
+        <p:spPr/>
+        <p:txBody>
+          <a:bodyPr>
+            <a:normAutofit fontScale="90000"/>
+          </a:bodyPr>
+          <a:lstStyle/>
+          <a:p>
+            <a:endParaRPr lang="en-ID"/>
+          </a:p>
+        </p:txBody>
+      </p:sp>
+    </p:spTree>
+    <p:extLst>
+      <p:ext uri="{BB962C8B-B14F-4D97-AF65-F5344CB8AC3E}">
+        <p14:creationId xmlns:p14="http://schemas.microsoft.com/office/powerpoint/2010/main" val="3892127728"/>
+      </p:ext>
+    </p:extLst>
+  </p:cSld>
+  <p:clrMapOvr>
+    <a:masterClrMapping/>
+  </p:clrMapOvr>
+</p:sld>
+</file>
+
+<file path=ppt/slides/slide6.xml><?xml version="1.0" encoding="utf-8"?>
+<p:sld xmlns:a="http://schemas.openxmlformats.org/drawingml/2006/main" xmlns:r="http://schemas.openxmlformats.org/officeDocument/2006/relationships" xmlns:p="http://schemas.openxmlformats.org/presentationml/2006/main">
+  <p:cSld>
+    <p:bg>
+      <p:bgPr>
+        <a:blipFill>
+          <a:blip r:embed="rId3"/>
+          <a:stretch>
+            <a:fillRect/>
+          </a:stretch>
+        </a:blipFill>
+        <a:effectLst/>
+      </p:bgPr>
+    </p:bg>
+    <p:spTree>
+      <p:nvGrpSpPr>
+        <p:cNvPr id="1" name="Shape 65">
+          <a:extLst>
+            <a:ext uri="{FF2B5EF4-FFF2-40B4-BE49-F238E27FC236}">
+              <a16:creationId xmlns:a16="http://schemas.microsoft.com/office/drawing/2014/main" id="{12D3925E-80E8-B29F-04BB-63BBBFE47672}"/>
+            </a:ext>
+          </a:extLst>
+        </p:cNvPr>
+        <p:cNvGrpSpPr/>
+        <p:nvPr/>
+      </p:nvGrpSpPr>
+      <p:grpSpPr>
+        <a:xfrm>
+          <a:off x="0" y="0"/>
+          <a:ext cx="0" cy="0"/>
+          <a:chOff x="0" y="0"/>
+          <a:chExt cx="0" cy="0"/>
+        </a:xfrm>
+      </p:grpSpPr>
+      <p:sp>
+        <p:nvSpPr>
+          <p:cNvPr id="5" name="Title 4">
+            <a:extLst>
+              <a:ext uri="{FF2B5EF4-FFF2-40B4-BE49-F238E27FC236}">
+                <a16:creationId xmlns:a16="http://schemas.microsoft.com/office/drawing/2014/main" id="{69DF9688-34DB-E4BC-A280-3B02F34F36AB}"/>
+              </a:ext>
+            </a:extLst>
+          </p:cNvPr>
+          <p:cNvSpPr>
+            <a:spLocks noGrp="1"/>
+          </p:cNvSpPr>
+          <p:nvPr>
+            <p:ph type="title"/>
+          </p:nvPr>
+        </p:nvSpPr>
+        <p:spPr/>
+        <p:txBody>
+          <a:bodyPr>
+            <a:normAutofit fontScale="90000"/>
+          </a:bodyPr>
+          <a:lstStyle/>
+          <a:p>
+            <a:endParaRPr lang="en-ID"/>
+          </a:p>
+        </p:txBody>
+      </p:sp>
+    </p:spTree>
+    <p:extLst>
+      <p:ext uri="{BB962C8B-B14F-4D97-AF65-F5344CB8AC3E}">
+        <p14:creationId xmlns:p14="http://schemas.microsoft.com/office/powerpoint/2010/main" val="3356628504"/>
+      </p:ext>
+    </p:extLst>
+  </p:cSld>
+  <p:clrMapOvr>
+    <a:masterClrMapping/>
+  </p:clrMapOvr>
+</p:sld>
+</file>
+
+<file path=ppt/slides/slide7.xml><?xml version="1.0" encoding="utf-8"?>
+<p:sld xmlns:a="http://schemas.openxmlformats.org/drawingml/2006/main" xmlns:r="http://schemas.openxmlformats.org/officeDocument/2006/relationships" xmlns:p="http://schemas.openxmlformats.org/presentationml/2006/main">
+  <p:cSld>
+    <p:bg>
+      <p:bgPr>
+        <a:blipFill>
+          <a:blip r:embed="rId3"/>
+          <a:stretch>
+            <a:fillRect/>
+          </a:stretch>
+        </a:blipFill>
+        <a:effectLst/>
+      </p:bgPr>
+    </p:bg>
+    <p:spTree>
+      <p:nvGrpSpPr>
+        <p:cNvPr id="1" name="Shape 65">
+          <a:extLst>
+            <a:ext uri="{FF2B5EF4-FFF2-40B4-BE49-F238E27FC236}">
+              <a16:creationId xmlns:a16="http://schemas.microsoft.com/office/drawing/2014/main" id="{576672C9-1209-F7C7-1A25-228ECDABB35F}"/>
+            </a:ext>
+          </a:extLst>
+        </p:cNvPr>
+        <p:cNvGrpSpPr/>
+        <p:nvPr/>
+      </p:nvGrpSpPr>
+      <p:grpSpPr>
+        <a:xfrm>
+          <a:off x="0" y="0"/>
+          <a:ext cx="0" cy="0"/>
+          <a:chOff x="0" y="0"/>
+          <a:chExt cx="0" cy="0"/>
+        </a:xfrm>
+      </p:grpSpPr>
+      <p:sp>
+        <p:nvSpPr>
+          <p:cNvPr id="5" name="Title 4">
+            <a:extLst>
+              <a:ext uri="{FF2B5EF4-FFF2-40B4-BE49-F238E27FC236}">
+                <a16:creationId xmlns:a16="http://schemas.microsoft.com/office/drawing/2014/main" id="{7BD5FA52-ACF5-861A-3BC7-5496629EAA8D}"/>
+              </a:ext>
+            </a:extLst>
+          </p:cNvPr>
+          <p:cNvSpPr>
+            <a:spLocks noGrp="1"/>
+          </p:cNvSpPr>
+          <p:nvPr>
+            <p:ph type="title"/>
+          </p:nvPr>
+        </p:nvSpPr>
+        <p:spPr/>
+        <p:txBody>
+          <a:bodyPr>
+            <a:normAutofit fontScale="90000"/>
+          </a:bodyPr>
+          <a:lstStyle/>
+          <a:p>
+            <a:endParaRPr lang="en-ID"/>
+          </a:p>
+        </p:txBody>
+      </p:sp>
+    </p:spTree>
+    <p:extLst>
+      <p:ext uri="{BB962C8B-B14F-4D97-AF65-F5344CB8AC3E}">
+        <p14:creationId xmlns:p14="http://schemas.microsoft.com/office/powerpoint/2010/main" val="3674420193"/>
+      </p:ext>
+    </p:extLst>
+  </p:cSld>
+  <p:clrMapOvr>
+    <a:masterClrMapping/>
+  </p:clrMapOvr>
+</p:sld>
+</file>
+
+<file path=ppt/slides/slide8.xml><?xml version="1.0" encoding="utf-8"?>
+<p:sld xmlns:a="http://schemas.openxmlformats.org/drawingml/2006/main" xmlns:r="http://schemas.openxmlformats.org/officeDocument/2006/relationships" xmlns:p="http://schemas.openxmlformats.org/presentationml/2006/main">
+  <p:cSld>
+    <p:bg>
+      <p:bgPr>
+        <a:blipFill>
+          <a:blip r:embed="rId3"/>
+          <a:stretch>
+            <a:fillRect/>
+          </a:stretch>
+        </a:blipFill>
+        <a:effectLst/>
+      </p:bgPr>
+    </p:bg>
+    <p:spTree>
+      <p:nvGrpSpPr>
+        <p:cNvPr id="1" name="Shape 65">
+          <a:extLst>
+            <a:ext uri="{FF2B5EF4-FFF2-40B4-BE49-F238E27FC236}">
+              <a16:creationId xmlns:a16="http://schemas.microsoft.com/office/drawing/2014/main" id="{FB602098-D1C6-EF02-6157-47FD5E079D6C}"/>
+            </a:ext>
+          </a:extLst>
+        </p:cNvPr>
+        <p:cNvGrpSpPr/>
+        <p:nvPr/>
+      </p:nvGrpSpPr>
+      <p:grpSpPr>
+        <a:xfrm>
+          <a:off x="0" y="0"/>
+          <a:ext cx="0" cy="0"/>
+          <a:chOff x="0" y="0"/>
+          <a:chExt cx="0" cy="0"/>
+        </a:xfrm>
+      </p:grpSpPr>
+      <p:sp>
+        <p:nvSpPr>
+          <p:cNvPr id="5" name="Title 4">
+            <a:extLst>
+              <a:ext uri="{FF2B5EF4-FFF2-40B4-BE49-F238E27FC236}">
+                <a16:creationId xmlns:a16="http://schemas.microsoft.com/office/drawing/2014/main" id="{3CA01E7A-A4B2-825F-EFCB-B17EEF593A53}"/>
+              </a:ext>
+            </a:extLst>
+          </p:cNvPr>
+          <p:cNvSpPr>
+            <a:spLocks noGrp="1"/>
+          </p:cNvSpPr>
+          <p:nvPr>
+            <p:ph type="title"/>
+          </p:nvPr>
+        </p:nvSpPr>
+        <p:spPr/>
+        <p:txBody>
+          <a:bodyPr>
+            <a:normAutofit fontScale="90000"/>
+          </a:bodyPr>
+          <a:lstStyle/>
+          <a:p>
+            <a:endParaRPr lang="en-ID"/>
+          </a:p>
+        </p:txBody>
+      </p:sp>
+    </p:spTree>
+    <p:extLst>
+      <p:ext uri="{BB962C8B-B14F-4D97-AF65-F5344CB8AC3E}">
+        <p14:creationId xmlns:p14="http://schemas.microsoft.com/office/powerpoint/2010/main" val="2003159494"/>
+      </p:ext>
+    </p:extLst>
+  </p:cSld>
+  <p:clrMapOvr>
+    <a:masterClrMapping/>
+  </p:clrMapOvr>
+</p:sld>
+</file>
+
+<file path=ppt/slides/slide9.xml><?xml version="1.0" encoding="utf-8"?>
+<p:sld xmlns:a="http://schemas.openxmlformats.org/drawingml/2006/main" xmlns:r="http://schemas.openxmlformats.org/officeDocument/2006/relationships" xmlns:p="http://schemas.openxmlformats.org/presentationml/2006/main">
+  <p:cSld>
+    <p:bg>
+      <p:bgPr>
+        <a:blipFill>
+          <a:blip r:embed="rId3"/>
+          <a:stretch>
+            <a:fillRect/>
+          </a:stretch>
+        </a:blipFill>
+        <a:effectLst/>
+      </p:bgPr>
+    </p:bg>
+    <p:spTree>
+      <p:nvGrpSpPr>
+        <p:cNvPr id="1" name="Shape 65">
+          <a:extLst>
+            <a:ext uri="{FF2B5EF4-FFF2-40B4-BE49-F238E27FC236}">
+              <a16:creationId xmlns:a16="http://schemas.microsoft.com/office/drawing/2014/main" id="{8ECD8376-EC0C-5273-1D07-26C8C70BD0BF}"/>
+            </a:ext>
+          </a:extLst>
+        </p:cNvPr>
+        <p:cNvGrpSpPr/>
+        <p:nvPr/>
+      </p:nvGrpSpPr>
+      <p:grpSpPr>
+        <a:xfrm>
+          <a:off x="0" y="0"/>
+          <a:ext cx="0" cy="0"/>
+          <a:chOff x="0" y="0"/>
+          <a:chExt cx="0" cy="0"/>
+        </a:xfrm>
+      </p:grpSpPr>
+      <p:sp>
+        <p:nvSpPr>
+          <p:cNvPr id="5" name="Title 4">
+            <a:extLst>
+              <a:ext uri="{FF2B5EF4-FFF2-40B4-BE49-F238E27FC236}">
+                <a16:creationId xmlns:a16="http://schemas.microsoft.com/office/drawing/2014/main" id="{1BC8AB82-0014-868E-AB71-45EC83BCCB7E}"/>
+              </a:ext>
+            </a:extLst>
+          </p:cNvPr>
+          <p:cNvSpPr>
+            <a:spLocks noGrp="1"/>
+          </p:cNvSpPr>
+          <p:nvPr>
+            <p:ph type="title"/>
+          </p:nvPr>
+        </p:nvSpPr>
+        <p:spPr/>
+        <p:txBody>
+          <a:bodyPr>
+            <a:normAutofit fontScale="90000"/>
+          </a:bodyPr>
+          <a:lstStyle/>
+          <a:p>
+            <a:endParaRPr lang="en-ID"/>
+          </a:p>
+        </p:txBody>
+      </p:sp>
+    </p:spTree>
+    <p:extLst>
+      <p:ext uri="{BB962C8B-B14F-4D97-AF65-F5344CB8AC3E}">
+        <p14:creationId xmlns:p14="http://schemas.microsoft.com/office/powerpoint/2010/main" val="2060672620"/>
+      </p:ext>
+    </p:extLst>
   </p:cSld>
   <p:clrMapOvr>
     <a:masterClrMapping/>

</xml_diff>